<commit_message>
modifications to 38 and 39
</commit_message>
<xml_diff>
--- a/Lecture_Slides/PH 123 Lecture 39.pptx
+++ b/Lecture_Slides/PH 123 Lecture 39.pptx
@@ -9,38 +9,36 @@
     <p:sldId id="295" r:id="rId3"/>
     <p:sldId id="296" r:id="rId4"/>
     <p:sldId id="297" r:id="rId5"/>
-    <p:sldId id="298" r:id="rId6"/>
-    <p:sldId id="289" r:id="rId7"/>
-    <p:sldId id="285" r:id="rId8"/>
-    <p:sldId id="287" r:id="rId9"/>
-    <p:sldId id="288" r:id="rId10"/>
-    <p:sldId id="486" r:id="rId11"/>
-    <p:sldId id="299" r:id="rId12"/>
-    <p:sldId id="302" r:id="rId13"/>
-    <p:sldId id="303" r:id="rId14"/>
-    <p:sldId id="304" r:id="rId15"/>
+    <p:sldId id="289" r:id="rId6"/>
+    <p:sldId id="285" r:id="rId7"/>
+    <p:sldId id="287" r:id="rId8"/>
+    <p:sldId id="288" r:id="rId9"/>
+    <p:sldId id="298" r:id="rId10"/>
+    <p:sldId id="302" r:id="rId11"/>
+    <p:sldId id="486" r:id="rId12"/>
+    <p:sldId id="299" r:id="rId13"/>
+    <p:sldId id="304" r:id="rId14"/>
+    <p:sldId id="303" r:id="rId15"/>
     <p:sldId id="305" r:id="rId16"/>
     <p:sldId id="306" r:id="rId17"/>
     <p:sldId id="307" r:id="rId18"/>
-    <p:sldId id="308" r:id="rId19"/>
-    <p:sldId id="309" r:id="rId20"/>
-    <p:sldId id="310" r:id="rId21"/>
-    <p:sldId id="311" r:id="rId22"/>
-    <p:sldId id="312" r:id="rId23"/>
-    <p:sldId id="313" r:id="rId24"/>
-    <p:sldId id="314" r:id="rId25"/>
-    <p:sldId id="315" r:id="rId26"/>
-    <p:sldId id="316" r:id="rId27"/>
-    <p:sldId id="317" r:id="rId28"/>
-    <p:sldId id="318" r:id="rId29"/>
-    <p:sldId id="300" r:id="rId30"/>
-    <p:sldId id="301" r:id="rId31"/>
-    <p:sldId id="290" r:id="rId32"/>
-    <p:sldId id="291" r:id="rId33"/>
-    <p:sldId id="292" r:id="rId34"/>
-    <p:sldId id="293" r:id="rId35"/>
-    <p:sldId id="294" r:id="rId36"/>
-    <p:sldId id="485" r:id="rId37"/>
+    <p:sldId id="310" r:id="rId19"/>
+    <p:sldId id="311" r:id="rId20"/>
+    <p:sldId id="312" r:id="rId21"/>
+    <p:sldId id="313" r:id="rId22"/>
+    <p:sldId id="314" r:id="rId23"/>
+    <p:sldId id="315" r:id="rId24"/>
+    <p:sldId id="316" r:id="rId25"/>
+    <p:sldId id="317" r:id="rId26"/>
+    <p:sldId id="318" r:id="rId27"/>
+    <p:sldId id="300" r:id="rId28"/>
+    <p:sldId id="301" r:id="rId29"/>
+    <p:sldId id="290" r:id="rId30"/>
+    <p:sldId id="291" r:id="rId31"/>
+    <p:sldId id="292" r:id="rId32"/>
+    <p:sldId id="293" r:id="rId33"/>
+    <p:sldId id="294" r:id="rId34"/>
+    <p:sldId id="485" r:id="rId35"/>
   </p:sldIdLst>
   <p:sldSz cx="12192000" cy="6858000"/>
   <p:notesSz cx="6858000" cy="9144000"/>
@@ -150,7 +148,6 @@
 <file path=ppt/revisionInfo.xml><?xml version="1.0" encoding="utf-8"?>
 <p1510:revInfo xmlns:a="http://schemas.openxmlformats.org/drawingml/2006/main" xmlns:r="http://schemas.openxmlformats.org/officeDocument/2006/relationships" xmlns:p1510="http://schemas.microsoft.com/office/powerpoint/2015/10/main">
   <p1510:revLst>
-    <p1510:client id="{19433E2F-A7AC-4341-9FA4-5680B2C19CE3}" v="2" dt="2025-07-08T19:01:42.760"/>
     <p1510:client id="{8BCAB8E9-8842-4BCB-9A37-B9C19E4A0765}" v="2" dt="2025-07-08T22:05:37.172"/>
   </p1510:revLst>
 </p1510:revInfo>
@@ -235,22 +232,6 @@
           <pc:docMk/>
           <pc:sldMk cId="812188704" sldId="485"/>
         </pc:sldMkLst>
-        <pc:spChg chg="del mod ord">
-          <ac:chgData name="Lines, Todd" userId="afaf7c3a-e8aa-4568-882a-02ad8f9e19b0" providerId="ADAL" clId="{15C103A9-F942-4ACA-ACF2-A6EEDACA0042}" dt="2025-07-08T20:13:27.529" v="3" actId="700"/>
-          <ac:spMkLst>
-            <pc:docMk/>
-            <pc:sldMk cId="812188704" sldId="485"/>
-            <ac:spMk id="2" creationId="{613CB161-11B3-7B09-9EEF-82AA48AB1AC3}"/>
-          </ac:spMkLst>
-        </pc:spChg>
-        <pc:spChg chg="del mod ord">
-          <ac:chgData name="Lines, Todd" userId="afaf7c3a-e8aa-4568-882a-02ad8f9e19b0" providerId="ADAL" clId="{15C103A9-F942-4ACA-ACF2-A6EEDACA0042}" dt="2025-07-08T20:13:27.529" v="3" actId="700"/>
-          <ac:spMkLst>
-            <pc:docMk/>
-            <pc:sldMk cId="812188704" sldId="485"/>
-            <ac:spMk id="3" creationId="{9FE61B34-194C-C2D6-5028-2B266CA81C38}"/>
-          </ac:spMkLst>
-        </pc:spChg>
         <pc:spChg chg="add mod ord">
           <ac:chgData name="Lines, Todd" userId="afaf7c3a-e8aa-4568-882a-02ad8f9e19b0" providerId="ADAL" clId="{15C103A9-F942-4ACA-ACF2-A6EEDACA0042}" dt="2025-07-08T20:13:29.685" v="6" actId="20577"/>
           <ac:spMkLst>
@@ -272,8 +253,8 @@
   </pc:docChgLst>
   <pc:docChgLst>
     <pc:chgData name="Lines, Todd" userId="afaf7c3a-e8aa-4568-882a-02ad8f9e19b0" providerId="ADAL" clId="{8BCAB8E9-8842-4BCB-9A37-B9C19E4A0765}"/>
-    <pc:docChg chg="custSel addSld delSld modSld">
-      <pc:chgData name="Lines, Todd" userId="afaf7c3a-e8aa-4568-882a-02ad8f9e19b0" providerId="ADAL" clId="{8BCAB8E9-8842-4BCB-9A37-B9C19E4A0765}" dt="2025-07-08T22:37:37.642" v="14" actId="47"/>
+    <pc:docChg chg="custSel addSld delSld modSld sldOrd">
+      <pc:chgData name="Lines, Todd" userId="afaf7c3a-e8aa-4568-882a-02ad8f9e19b0" providerId="ADAL" clId="{8BCAB8E9-8842-4BCB-9A37-B9C19E4A0765}" dt="2025-07-17T20:10:37.761" v="24" actId="207"/>
       <pc:docMkLst>
         <pc:docMk/>
       </pc:docMkLst>
@@ -312,14 +293,6 @@
           <pc:docMk/>
           <pc:sldMk cId="0" sldId="284"/>
         </pc:sldMkLst>
-        <pc:spChg chg="mod">
-          <ac:chgData name="Lines, Todd" userId="afaf7c3a-e8aa-4568-882a-02ad8f9e19b0" providerId="ADAL" clId="{8BCAB8E9-8842-4BCB-9A37-B9C19E4A0765}" dt="2025-07-08T22:37:34.651" v="13" actId="6549"/>
-          <ac:spMkLst>
-            <pc:docMk/>
-            <pc:sldMk cId="0" sldId="284"/>
-            <ac:spMk id="9223" creationId="{00000000-0000-0000-0000-000000000000}"/>
-          </ac:spMkLst>
-        </pc:spChg>
       </pc:sldChg>
       <pc:sldChg chg="add">
         <pc:chgData name="Lines, Todd" userId="afaf7c3a-e8aa-4568-882a-02ad8f9e19b0" providerId="ADAL" clId="{8BCAB8E9-8842-4BCB-9A37-B9C19E4A0765}" dt="2025-07-08T21:53:03.792" v="2"/>
@@ -379,7 +352,7 @@
         </pc:sldMkLst>
       </pc:sldChg>
       <pc:sldChg chg="modSp add mod">
-        <pc:chgData name="Lines, Todd" userId="afaf7c3a-e8aa-4568-882a-02ad8f9e19b0" providerId="ADAL" clId="{8BCAB8E9-8842-4BCB-9A37-B9C19E4A0765}" dt="2025-07-08T21:53:03.913" v="6" actId="27636"/>
+        <pc:chgData name="Lines, Todd" userId="afaf7c3a-e8aa-4568-882a-02ad8f9e19b0" providerId="ADAL" clId="{8BCAB8E9-8842-4BCB-9A37-B9C19E4A0765}" dt="2025-07-17T20:10:27.223" v="23" actId="207"/>
         <pc:sldMkLst>
           <pc:docMk/>
           <pc:sldMk cId="0" sldId="292"/>
@@ -392,13 +365,29 @@
             <ac:spMk id="3074" creationId="{00000000-0000-0000-0000-000000000000}"/>
           </ac:spMkLst>
         </pc:spChg>
+        <pc:spChg chg="mod">
+          <ac:chgData name="Lines, Todd" userId="afaf7c3a-e8aa-4568-882a-02ad8f9e19b0" providerId="ADAL" clId="{8BCAB8E9-8842-4BCB-9A37-B9C19E4A0765}" dt="2025-07-17T20:10:27.223" v="23" actId="207"/>
+          <ac:spMkLst>
+            <pc:docMk/>
+            <pc:sldMk cId="0" sldId="292"/>
+            <ac:spMk id="3076" creationId="{00000000-0000-0000-0000-000000000000}"/>
+          </ac:spMkLst>
+        </pc:spChg>
       </pc:sldChg>
-      <pc:sldChg chg="add">
-        <pc:chgData name="Lines, Todd" userId="afaf7c3a-e8aa-4568-882a-02ad8f9e19b0" providerId="ADAL" clId="{8BCAB8E9-8842-4BCB-9A37-B9C19E4A0765}" dt="2025-07-08T21:53:03.792" v="2"/>
+      <pc:sldChg chg="modSp add mod">
+        <pc:chgData name="Lines, Todd" userId="afaf7c3a-e8aa-4568-882a-02ad8f9e19b0" providerId="ADAL" clId="{8BCAB8E9-8842-4BCB-9A37-B9C19E4A0765}" dt="2025-07-17T20:10:37.761" v="24" actId="207"/>
         <pc:sldMkLst>
           <pc:docMk/>
           <pc:sldMk cId="0" sldId="293"/>
         </pc:sldMkLst>
+        <pc:spChg chg="mod">
+          <ac:chgData name="Lines, Todd" userId="afaf7c3a-e8aa-4568-882a-02ad8f9e19b0" providerId="ADAL" clId="{8BCAB8E9-8842-4BCB-9A37-B9C19E4A0765}" dt="2025-07-17T20:10:37.761" v="24" actId="207"/>
+          <ac:spMkLst>
+            <pc:docMk/>
+            <pc:sldMk cId="0" sldId="293"/>
+            <ac:spMk id="4100" creationId="{00000000-0000-0000-0000-000000000000}"/>
+          </ac:spMkLst>
+        </pc:spChg>
       </pc:sldChg>
       <pc:sldChg chg="add">
         <pc:chgData name="Lines, Todd" userId="afaf7c3a-e8aa-4568-882a-02ad8f9e19b0" providerId="ADAL" clId="{8BCAB8E9-8842-4BCB-9A37-B9C19E4A0765}" dt="2025-07-08T21:53:03.792" v="2"/>
@@ -428,8 +417,8 @@
           <pc:sldMk cId="3090657162" sldId="297"/>
         </pc:sldMkLst>
       </pc:sldChg>
-      <pc:sldChg chg="add">
-        <pc:chgData name="Lines, Todd" userId="afaf7c3a-e8aa-4568-882a-02ad8f9e19b0" providerId="ADAL" clId="{8BCAB8E9-8842-4BCB-9A37-B9C19E4A0765}" dt="2025-07-08T21:53:03.792" v="2"/>
+      <pc:sldChg chg="add ord">
+        <pc:chgData name="Lines, Todd" userId="afaf7c3a-e8aa-4568-882a-02ad8f9e19b0" providerId="ADAL" clId="{8BCAB8E9-8842-4BCB-9A37-B9C19E4A0765}" dt="2025-07-17T19:16:53.996" v="16"/>
         <pc:sldMkLst>
           <pc:docMk/>
           <pc:sldMk cId="2413419914" sldId="298"/>
@@ -464,15 +453,15 @@
           <pc:sldMk cId="3055023919" sldId="301"/>
         </pc:sldMkLst>
       </pc:sldChg>
-      <pc:sldChg chg="add">
-        <pc:chgData name="Lines, Todd" userId="afaf7c3a-e8aa-4568-882a-02ad8f9e19b0" providerId="ADAL" clId="{8BCAB8E9-8842-4BCB-9A37-B9C19E4A0765}" dt="2025-07-08T21:53:03.792" v="2"/>
+      <pc:sldChg chg="add ord">
+        <pc:chgData name="Lines, Todd" userId="afaf7c3a-e8aa-4568-882a-02ad8f9e19b0" providerId="ADAL" clId="{8BCAB8E9-8842-4BCB-9A37-B9C19E4A0765}" dt="2025-07-17T19:30:15.773" v="18"/>
         <pc:sldMkLst>
           <pc:docMk/>
           <pc:sldMk cId="2409103529" sldId="302"/>
         </pc:sldMkLst>
       </pc:sldChg>
-      <pc:sldChg chg="add">
-        <pc:chgData name="Lines, Todd" userId="afaf7c3a-e8aa-4568-882a-02ad8f9e19b0" providerId="ADAL" clId="{8BCAB8E9-8842-4BCB-9A37-B9C19E4A0765}" dt="2025-07-08T21:53:03.792" v="2"/>
+      <pc:sldChg chg="add ord">
+        <pc:chgData name="Lines, Todd" userId="afaf7c3a-e8aa-4568-882a-02ad8f9e19b0" providerId="ADAL" clId="{8BCAB8E9-8842-4BCB-9A37-B9C19E4A0765}" dt="2025-07-17T19:30:33.580" v="20"/>
         <pc:sldMkLst>
           <pc:docMk/>
           <pc:sldMk cId="1836129507" sldId="303"/>
@@ -506,15 +495,15 @@
           <pc:sldMk cId="4006965037" sldId="307"/>
         </pc:sldMkLst>
       </pc:sldChg>
-      <pc:sldChg chg="add">
-        <pc:chgData name="Lines, Todd" userId="afaf7c3a-e8aa-4568-882a-02ad8f9e19b0" providerId="ADAL" clId="{8BCAB8E9-8842-4BCB-9A37-B9C19E4A0765}" dt="2025-07-08T21:53:03.792" v="2"/>
+      <pc:sldChg chg="add del">
+        <pc:chgData name="Lines, Todd" userId="afaf7c3a-e8aa-4568-882a-02ad8f9e19b0" providerId="ADAL" clId="{8BCAB8E9-8842-4BCB-9A37-B9C19E4A0765}" dt="2025-07-17T19:41:55.245" v="21" actId="47"/>
         <pc:sldMkLst>
           <pc:docMk/>
           <pc:sldMk cId="1266226493" sldId="308"/>
         </pc:sldMkLst>
       </pc:sldChg>
-      <pc:sldChg chg="add">
-        <pc:chgData name="Lines, Todd" userId="afaf7c3a-e8aa-4568-882a-02ad8f9e19b0" providerId="ADAL" clId="{8BCAB8E9-8842-4BCB-9A37-B9C19E4A0765}" dt="2025-07-08T21:53:03.792" v="2"/>
+      <pc:sldChg chg="add del">
+        <pc:chgData name="Lines, Todd" userId="afaf7c3a-e8aa-4568-882a-02ad8f9e19b0" providerId="ADAL" clId="{8BCAB8E9-8842-4BCB-9A37-B9C19E4A0765}" dt="2025-07-17T19:41:57.737" v="22" actId="47"/>
         <pc:sldMkLst>
           <pc:docMk/>
           <pc:sldMk cId="1735856818" sldId="309"/>
@@ -657,14 +646,6 @@
           <pc:docMk/>
           <pc:sldMk cId="0" sldId="484"/>
         </pc:sldMkLst>
-        <pc:spChg chg="mod">
-          <ac:chgData name="Lines, Todd" userId="afaf7c3a-e8aa-4568-882a-02ad8f9e19b0" providerId="ADAL" clId="{19433E2F-A7AC-4341-9FA4-5680B2C19CE3}" dt="2025-07-08T19:01:50.896" v="8" actId="20577"/>
-          <ac:spMkLst>
-            <pc:docMk/>
-            <pc:sldMk cId="0" sldId="484"/>
-            <ac:spMk id="35843" creationId="{25E6F564-0ACC-BFA0-5D1C-098F0645008F}"/>
-          </ac:spMkLst>
-        </pc:spChg>
       </pc:sldChg>
     </pc:docChg>
   </pc:docChgLst>
@@ -818,7 +799,7 @@
           <a:p>
             <a:fld id="{5D14FE54-3E4B-43AC-AC6A-78E009FC7A62}" type="datetimeFigureOut">
               <a:rPr lang="en-US" smtClean="0"/>
-              <a:t>7/8/2025</a:t>
+              <a:t>7/17/2025</a:t>
             </a:fld>
             <a:endParaRPr lang="en-US"/>
           </a:p>
@@ -1016,7 +997,7 @@
           <a:p>
             <a:fld id="{5D14FE54-3E4B-43AC-AC6A-78E009FC7A62}" type="datetimeFigureOut">
               <a:rPr lang="en-US" smtClean="0"/>
-              <a:t>7/8/2025</a:t>
+              <a:t>7/17/2025</a:t>
             </a:fld>
             <a:endParaRPr lang="en-US"/>
           </a:p>
@@ -1224,7 +1205,7 @@
           <a:p>
             <a:fld id="{5D14FE54-3E4B-43AC-AC6A-78E009FC7A62}" type="datetimeFigureOut">
               <a:rPr lang="en-US" smtClean="0"/>
-              <a:t>7/8/2025</a:t>
+              <a:t>7/17/2025</a:t>
             </a:fld>
             <a:endParaRPr lang="en-US"/>
           </a:p>
@@ -1422,7 +1403,7 @@
           <a:p>
             <a:fld id="{5D14FE54-3E4B-43AC-AC6A-78E009FC7A62}" type="datetimeFigureOut">
               <a:rPr lang="en-US" smtClean="0"/>
-              <a:t>7/8/2025</a:t>
+              <a:t>7/17/2025</a:t>
             </a:fld>
             <a:endParaRPr lang="en-US"/>
           </a:p>
@@ -1697,7 +1678,7 @@
           <a:p>
             <a:fld id="{5D14FE54-3E4B-43AC-AC6A-78E009FC7A62}" type="datetimeFigureOut">
               <a:rPr lang="en-US" smtClean="0"/>
-              <a:t>7/8/2025</a:t>
+              <a:t>7/17/2025</a:t>
             </a:fld>
             <a:endParaRPr lang="en-US"/>
           </a:p>
@@ -1962,7 +1943,7 @@
           <a:p>
             <a:fld id="{5D14FE54-3E4B-43AC-AC6A-78E009FC7A62}" type="datetimeFigureOut">
               <a:rPr lang="en-US" smtClean="0"/>
-              <a:t>7/8/2025</a:t>
+              <a:t>7/17/2025</a:t>
             </a:fld>
             <a:endParaRPr lang="en-US"/>
           </a:p>
@@ -2374,7 +2355,7 @@
           <a:p>
             <a:fld id="{5D14FE54-3E4B-43AC-AC6A-78E009FC7A62}" type="datetimeFigureOut">
               <a:rPr lang="en-US" smtClean="0"/>
-              <a:t>7/8/2025</a:t>
+              <a:t>7/17/2025</a:t>
             </a:fld>
             <a:endParaRPr lang="en-US"/>
           </a:p>
@@ -2515,7 +2496,7 @@
           <a:p>
             <a:fld id="{5D14FE54-3E4B-43AC-AC6A-78E009FC7A62}" type="datetimeFigureOut">
               <a:rPr lang="en-US" smtClean="0"/>
-              <a:t>7/8/2025</a:t>
+              <a:t>7/17/2025</a:t>
             </a:fld>
             <a:endParaRPr lang="en-US"/>
           </a:p>
@@ -2628,7 +2609,7 @@
           <a:p>
             <a:fld id="{5D14FE54-3E4B-43AC-AC6A-78E009FC7A62}" type="datetimeFigureOut">
               <a:rPr lang="en-US" smtClean="0"/>
-              <a:t>7/8/2025</a:t>
+              <a:t>7/17/2025</a:t>
             </a:fld>
             <a:endParaRPr lang="en-US"/>
           </a:p>
@@ -2939,7 +2920,7 @@
           <a:p>
             <a:fld id="{5D14FE54-3E4B-43AC-AC6A-78E009FC7A62}" type="datetimeFigureOut">
               <a:rPr lang="en-US" smtClean="0"/>
-              <a:t>7/8/2025</a:t>
+              <a:t>7/17/2025</a:t>
             </a:fld>
             <a:endParaRPr lang="en-US"/>
           </a:p>
@@ -3227,7 +3208,7 @@
           <a:p>
             <a:fld id="{5D14FE54-3E4B-43AC-AC6A-78E009FC7A62}" type="datetimeFigureOut">
               <a:rPr lang="en-US" smtClean="0"/>
-              <a:t>7/8/2025</a:t>
+              <a:t>7/17/2025</a:t>
             </a:fld>
             <a:endParaRPr lang="en-US"/>
           </a:p>
@@ -3468,7 +3449,7 @@
           <a:p>
             <a:fld id="{5D14FE54-3E4B-43AC-AC6A-78E009FC7A62}" type="datetimeFigureOut">
               <a:rPr lang="en-US" smtClean="0"/>
-              <a:t>7/8/2025</a:t>
+              <a:t>7/17/2025</a:t>
             </a:fld>
             <a:endParaRPr lang="en-US"/>
           </a:p>
@@ -3969,6 +3950,121 @@
           <a:chExt cx="0" cy="0"/>
         </a:xfrm>
       </p:grpSpPr>
+      <p:sp>
+        <p:nvSpPr>
+          <p:cNvPr id="19458" name="Rectangle 2"/>
+          <p:cNvSpPr>
+            <a:spLocks noGrp="1" noChangeArrowheads="1"/>
+          </p:cNvSpPr>
+          <p:nvPr>
+            <p:ph type="title"/>
+          </p:nvPr>
+        </p:nvSpPr>
+        <p:spPr/>
+        <p:txBody>
+          <a:bodyPr/>
+          <a:lstStyle/>
+          <a:p>
+            <a:pPr eaLnBrk="1" hangingPunct="1"/>
+            <a:r>
+              <a:rPr lang="en-US"/>
+              <a:t>Probabilities: </a:t>
+            </a:r>
+          </a:p>
+        </p:txBody>
+      </p:sp>
+      <p:sp>
+        <p:nvSpPr>
+          <p:cNvPr id="19459" name="Rectangle 3"/>
+          <p:cNvSpPr>
+            <a:spLocks noGrp="1" noChangeArrowheads="1"/>
+          </p:cNvSpPr>
+          <p:nvPr>
+            <p:ph type="body" idx="1"/>
+          </p:nvPr>
+        </p:nvSpPr>
+        <p:spPr/>
+        <p:txBody>
+          <a:bodyPr/>
+          <a:lstStyle/>
+          <a:p>
+            <a:pPr eaLnBrk="1" hangingPunct="1"/>
+            <a:r>
+              <a:rPr lang="en-US"/>
+              <a:t>Two boxes:</a:t>
+            </a:r>
+          </a:p>
+          <a:p>
+            <a:pPr lvl="1" eaLnBrk="1" hangingPunct="1"/>
+            <a:r>
+              <a:rPr lang="en-US"/>
+              <a:t>One particle on left:  		½</a:t>
+            </a:r>
+          </a:p>
+          <a:p>
+            <a:pPr lvl="1" eaLnBrk="1" hangingPunct="1"/>
+            <a:r>
+              <a:rPr lang="en-US"/>
+              <a:t>Two particles on left:		¼</a:t>
+            </a:r>
+          </a:p>
+          <a:p>
+            <a:pPr lvl="1" eaLnBrk="1" hangingPunct="1"/>
+            <a:endParaRPr lang="en-US"/>
+          </a:p>
+          <a:p>
+            <a:pPr lvl="1" eaLnBrk="1" hangingPunct="1"/>
+            <a:r>
+              <a:rPr lang="en-US"/>
+              <a:t>50 particles on left:   1/1125899906842624</a:t>
+            </a:r>
+          </a:p>
+          <a:p>
+            <a:pPr eaLnBrk="1" hangingPunct="1"/>
+            <a:r>
+              <a:rPr lang="en-US"/>
+              <a:t>Two boxes, 100 particles, 50 slowest on one side, 50 fastest on the other</a:t>
+            </a:r>
+          </a:p>
+          <a:p>
+            <a:pPr lvl="1" eaLnBrk="1" hangingPunct="1"/>
+            <a:r>
+              <a:rPr lang="en-US"/>
+              <a:t>        1/1267650600228229401496703205376</a:t>
+            </a:r>
+          </a:p>
+        </p:txBody>
+      </p:sp>
+    </p:spTree>
+    <p:extLst>
+      <p:ext uri="{BB962C8B-B14F-4D97-AF65-F5344CB8AC3E}">
+        <p14:creationId xmlns:p14="http://schemas.microsoft.com/office/powerpoint/2010/main" val="2409103529"/>
+      </p:ext>
+    </p:extLst>
+  </p:cSld>
+  <p:clrMapOvr>
+    <a:masterClrMapping/>
+  </p:clrMapOvr>
+</p:sld>
+</file>
+
+<file path=ppt/slides/slide11.xml><?xml version="1.0" encoding="utf-8"?>
+<p:sld xmlns:a="http://schemas.openxmlformats.org/drawingml/2006/main" xmlns:r="http://schemas.openxmlformats.org/officeDocument/2006/relationships" xmlns:p="http://schemas.openxmlformats.org/presentationml/2006/main">
+  <p:cSld>
+    <p:spTree>
+      <p:nvGrpSpPr>
+        <p:cNvPr id="1" name=""/>
+        <p:cNvGrpSpPr/>
+        <p:nvPr/>
+      </p:nvGrpSpPr>
+      <p:grpSpPr>
+        <a:xfrm>
+          <a:off x="0" y="0"/>
+          <a:ext cx="0" cy="0"/>
+          <a:chOff x="0" y="0"/>
+          <a:chExt cx="0" cy="0"/>
+        </a:xfrm>
+      </p:grpSpPr>
       <p:pic>
         <p:nvPicPr>
           <p:cNvPr id="2" name="Online Media 1" title="The Smile">
@@ -4150,7 +4246,7 @@
 </p:sld>
 </file>
 
-<file path=ppt/slides/slide11.xml><?xml version="1.0" encoding="utf-8"?>
+<file path=ppt/slides/slide12.xml><?xml version="1.0" encoding="utf-8"?>
 <p:sld xmlns:a="http://schemas.openxmlformats.org/drawingml/2006/main" xmlns:r="http://schemas.openxmlformats.org/officeDocument/2006/relationships" xmlns:p="http://schemas.openxmlformats.org/presentationml/2006/main">
   <p:cSld>
     <p:spTree>
@@ -4330,7 +4426,7 @@
               <a:pPr>
                 <a:defRPr/>
               </a:pPr>
-              <a:t>11</a:t>
+              <a:t>12</a:t>
             </a:fld>
             <a:endParaRPr lang="en-US"/>
           </a:p>
@@ -4349,7 +4445,7 @@
 </p:sld>
 </file>
 
-<file path=ppt/slides/slide12.xml><?xml version="1.0" encoding="utf-8"?>
+<file path=ppt/slides/slide13.xml><?xml version="1.0" encoding="utf-8"?>
 <p:sld xmlns:a="http://schemas.openxmlformats.org/drawingml/2006/main" xmlns:r="http://schemas.openxmlformats.org/officeDocument/2006/relationships" xmlns:p="http://schemas.openxmlformats.org/presentationml/2006/main">
   <p:cSld>
     <p:spTree>
@@ -4368,7 +4464,7 @@
       </p:grpSpPr>
       <p:sp>
         <p:nvSpPr>
-          <p:cNvPr id="19458" name="Rectangle 2"/>
+          <p:cNvPr id="21506" name="Rectangle 2"/>
           <p:cNvSpPr>
             <a:spLocks noGrp="1" noChangeArrowheads="1"/>
           </p:cNvSpPr>
@@ -4376,22 +4472,27 @@
             <p:ph type="title"/>
           </p:nvPr>
         </p:nvSpPr>
-        <p:spPr/>
+        <p:spPr>
+          <a:xfrm>
+            <a:off x="2755901" y="0"/>
+            <a:ext cx="7623175" cy="1143000"/>
+          </a:xfrm>
+        </p:spPr>
         <p:txBody>
           <a:bodyPr/>
           <a:lstStyle/>
           <a:p>
             <a:pPr eaLnBrk="1" hangingPunct="1"/>
             <a:r>
-              <a:rPr lang="en-US"/>
-              <a:t>Probabilities: </a:t>
+              <a:rPr lang="en-US" sz="3200"/>
+              <a:t>Entropy, Molecule Example Extended</a:t>
             </a:r>
           </a:p>
         </p:txBody>
       </p:sp>
       <p:sp>
         <p:nvSpPr>
-          <p:cNvPr id="19459" name="Rectangle 3"/>
+          <p:cNvPr id="21507" name="Rectangle 3"/>
           <p:cNvSpPr>
             <a:spLocks noGrp="1" noChangeArrowheads="1"/>
           </p:cNvSpPr>
@@ -4407,46 +4508,26 @@
             <a:pPr eaLnBrk="1" hangingPunct="1"/>
             <a:r>
               <a:rPr lang="en-US"/>
-              <a:t>Two boxes:</a:t>
-            </a:r>
-          </a:p>
-          <a:p>
-            <a:pPr lvl="1" eaLnBrk="1" hangingPunct="1"/>
+              <a:t>Consider 100 molecules in the container</a:t>
+            </a:r>
+          </a:p>
+          <a:p>
+            <a:pPr eaLnBrk="1" hangingPunct="1"/>
             <a:r>
               <a:rPr lang="en-US"/>
-              <a:t>One particle on left:  		½</a:t>
-            </a:r>
-          </a:p>
-          <a:p>
-            <a:pPr lvl="1" eaLnBrk="1" hangingPunct="1"/>
+              <a:t>The probability of separating 50 fast molecules on one side and 50 slow molecules on the other side is (½)</a:t>
+            </a:r>
+            <a:r>
+              <a:rPr lang="en-US" baseline="30000"/>
+              <a:t>100</a:t>
+            </a:r>
+            <a:endParaRPr lang="en-US"/>
+          </a:p>
+          <a:p>
+            <a:pPr eaLnBrk="1" hangingPunct="1"/>
             <a:r>
               <a:rPr lang="en-US"/>
-              <a:t>Two particles on left:		¼</a:t>
-            </a:r>
-          </a:p>
-          <a:p>
-            <a:pPr lvl="1" eaLnBrk="1" hangingPunct="1"/>
-            <a:endParaRPr lang="en-US"/>
-          </a:p>
-          <a:p>
-            <a:pPr lvl="1" eaLnBrk="1" hangingPunct="1"/>
-            <a:r>
-              <a:rPr lang="en-US"/>
-              <a:t>50 particles on left:   1/1125899906842624</a:t>
-            </a:r>
-          </a:p>
-          <a:p>
-            <a:pPr eaLnBrk="1" hangingPunct="1"/>
-            <a:r>
-              <a:rPr lang="en-US"/>
-              <a:t>Two boxes, 100 particles, 50 slowest on one side, 50 fastest on the other</a:t>
-            </a:r>
-          </a:p>
-          <a:p>
-            <a:pPr lvl="1" eaLnBrk="1" hangingPunct="1"/>
-            <a:r>
-              <a:rPr lang="en-US"/>
-              <a:t>        1/1267650600228229401496703205376</a:t>
+              <a:t>If we have one mole of gas, this is found to be extremely improbable</a:t>
             </a:r>
           </a:p>
         </p:txBody>
@@ -4454,7 +4535,7 @@
     </p:spTree>
     <p:extLst>
       <p:ext uri="{BB962C8B-B14F-4D97-AF65-F5344CB8AC3E}">
-        <p14:creationId xmlns:p14="http://schemas.microsoft.com/office/powerpoint/2010/main" val="2409103529"/>
+        <p14:creationId xmlns:p14="http://schemas.microsoft.com/office/powerpoint/2010/main" val="352927780"/>
       </p:ext>
     </p:extLst>
   </p:cSld>
@@ -4464,7 +4545,7 @@
 </p:sld>
 </file>
 
-<file path=ppt/slides/slide13.xml><?xml version="1.0" encoding="utf-8"?>
+<file path=ppt/slides/slide14.xml><?xml version="1.0" encoding="utf-8"?>
 <p:sld xmlns:a="http://schemas.openxmlformats.org/drawingml/2006/main" xmlns:r="http://schemas.openxmlformats.org/officeDocument/2006/relationships" xmlns:p="http://schemas.openxmlformats.org/presentationml/2006/main">
   <p:cSld>
     <p:spTree>
@@ -4681,106 +4762,6 @@
 </p:sld>
 </file>
 
-<file path=ppt/slides/slide14.xml><?xml version="1.0" encoding="utf-8"?>
-<p:sld xmlns:a="http://schemas.openxmlformats.org/drawingml/2006/main" xmlns:r="http://schemas.openxmlformats.org/officeDocument/2006/relationships" xmlns:p="http://schemas.openxmlformats.org/presentationml/2006/main">
-  <p:cSld>
-    <p:spTree>
-      <p:nvGrpSpPr>
-        <p:cNvPr id="1" name=""/>
-        <p:cNvGrpSpPr/>
-        <p:nvPr/>
-      </p:nvGrpSpPr>
-      <p:grpSpPr>
-        <a:xfrm>
-          <a:off x="0" y="0"/>
-          <a:ext cx="0" cy="0"/>
-          <a:chOff x="0" y="0"/>
-          <a:chExt cx="0" cy="0"/>
-        </a:xfrm>
-      </p:grpSpPr>
-      <p:sp>
-        <p:nvSpPr>
-          <p:cNvPr id="21506" name="Rectangle 2"/>
-          <p:cNvSpPr>
-            <a:spLocks noGrp="1" noChangeArrowheads="1"/>
-          </p:cNvSpPr>
-          <p:nvPr>
-            <p:ph type="title"/>
-          </p:nvPr>
-        </p:nvSpPr>
-        <p:spPr>
-          <a:xfrm>
-            <a:off x="2755901" y="0"/>
-            <a:ext cx="7623175" cy="1143000"/>
-          </a:xfrm>
-        </p:spPr>
-        <p:txBody>
-          <a:bodyPr/>
-          <a:lstStyle/>
-          <a:p>
-            <a:pPr eaLnBrk="1" hangingPunct="1"/>
-            <a:r>
-              <a:rPr lang="en-US" sz="3200"/>
-              <a:t>Entropy, Molecule Example Extended</a:t>
-            </a:r>
-          </a:p>
-        </p:txBody>
-      </p:sp>
-      <p:sp>
-        <p:nvSpPr>
-          <p:cNvPr id="21507" name="Rectangle 3"/>
-          <p:cNvSpPr>
-            <a:spLocks noGrp="1" noChangeArrowheads="1"/>
-          </p:cNvSpPr>
-          <p:nvPr>
-            <p:ph type="body" idx="1"/>
-          </p:nvPr>
-        </p:nvSpPr>
-        <p:spPr/>
-        <p:txBody>
-          <a:bodyPr/>
-          <a:lstStyle/>
-          <a:p>
-            <a:pPr eaLnBrk="1" hangingPunct="1"/>
-            <a:r>
-              <a:rPr lang="en-US"/>
-              <a:t>Consider 100 molecules in the container</a:t>
-            </a:r>
-          </a:p>
-          <a:p>
-            <a:pPr eaLnBrk="1" hangingPunct="1"/>
-            <a:r>
-              <a:rPr lang="en-US"/>
-              <a:t>The probability of separating 50 fast molecules on one side and 50 slow molecules on the other side is (½)</a:t>
-            </a:r>
-            <a:r>
-              <a:rPr lang="en-US" baseline="30000"/>
-              <a:t>100</a:t>
-            </a:r>
-            <a:endParaRPr lang="en-US"/>
-          </a:p>
-          <a:p>
-            <a:pPr eaLnBrk="1" hangingPunct="1"/>
-            <a:r>
-              <a:rPr lang="en-US"/>
-              <a:t>If we have one mole of gas, this is found to be extremely improbable</a:t>
-            </a:r>
-          </a:p>
-        </p:txBody>
-      </p:sp>
-    </p:spTree>
-    <p:extLst>
-      <p:ext uri="{BB962C8B-B14F-4D97-AF65-F5344CB8AC3E}">
-        <p14:creationId xmlns:p14="http://schemas.microsoft.com/office/powerpoint/2010/main" val="352927780"/>
-      </p:ext>
-    </p:extLst>
-  </p:cSld>
-  <p:clrMapOvr>
-    <a:masterClrMapping/>
-  </p:clrMapOvr>
-</p:sld>
-</file>
-
 <file path=ppt/slides/slide15.xml><?xml version="1.0" encoding="utf-8"?>
 <p:sld xmlns:a="http://schemas.openxmlformats.org/drawingml/2006/main" xmlns:r="http://schemas.openxmlformats.org/officeDocument/2006/relationships" xmlns:p="http://schemas.openxmlformats.org/presentationml/2006/main">
   <p:cSld>
@@ -5262,433 +5243,6 @@
       </p:grpSpPr>
       <p:sp>
         <p:nvSpPr>
-          <p:cNvPr id="23554" name="Rectangle 2"/>
-          <p:cNvSpPr>
-            <a:spLocks noGrp="1" noChangeArrowheads="1"/>
-          </p:cNvSpPr>
-          <p:nvPr>
-            <p:ph type="title"/>
-          </p:nvPr>
-        </p:nvSpPr>
-        <p:spPr/>
-        <p:txBody>
-          <a:bodyPr/>
-          <a:lstStyle/>
-          <a:p>
-            <a:pPr eaLnBrk="1" hangingPunct="1"/>
-            <a:r>
-              <a:rPr lang="en-US"/>
-              <a:t>Change in Entropy, cont</a:t>
-            </a:r>
-          </a:p>
-        </p:txBody>
-      </p:sp>
-      <p:sp>
-        <p:nvSpPr>
-          <p:cNvPr id="23555" name="Rectangle 3"/>
-          <p:cNvSpPr>
-            <a:spLocks noGrp="1" noChangeArrowheads="1"/>
-          </p:cNvSpPr>
-          <p:nvPr>
-            <p:ph type="body" idx="1"/>
-          </p:nvPr>
-        </p:nvSpPr>
-        <p:spPr/>
-        <p:txBody>
-          <a:bodyPr/>
-          <a:lstStyle/>
-          <a:p>
-            <a:pPr eaLnBrk="1" hangingPunct="1"/>
-            <a:r>
-              <a:rPr lang="en-US"/>
-              <a:t>The change in entropy of a system going from one state to another has the same value for all paths connecting the two states</a:t>
-            </a:r>
-          </a:p>
-          <a:p>
-            <a:pPr eaLnBrk="1" hangingPunct="1"/>
-            <a:r>
-              <a:rPr lang="en-US"/>
-              <a:t>The finite change in entropy depends only on the properties of the initial and final equilibrium states</a:t>
-            </a:r>
-          </a:p>
-        </p:txBody>
-      </p:sp>
-    </p:spTree>
-    <p:extLst>
-      <p:ext uri="{BB962C8B-B14F-4D97-AF65-F5344CB8AC3E}">
-        <p14:creationId xmlns:p14="http://schemas.microsoft.com/office/powerpoint/2010/main" val="1266226493"/>
-      </p:ext>
-    </p:extLst>
-  </p:cSld>
-  <p:clrMapOvr>
-    <a:masterClrMapping/>
-  </p:clrMapOvr>
-</p:sld>
-</file>
-
-<file path=ppt/slides/slide19.xml><?xml version="1.0" encoding="utf-8"?>
-<p:sld xmlns:a="http://schemas.openxmlformats.org/drawingml/2006/main" xmlns:r="http://schemas.openxmlformats.org/officeDocument/2006/relationships" xmlns:p="http://schemas.openxmlformats.org/presentationml/2006/main">
-  <p:cSld>
-    <p:spTree>
-      <p:nvGrpSpPr>
-        <p:cNvPr id="1" name=""/>
-        <p:cNvGrpSpPr/>
-        <p:nvPr/>
-      </p:nvGrpSpPr>
-      <p:grpSpPr>
-        <a:xfrm>
-          <a:off x="0" y="0"/>
-          <a:ext cx="0" cy="0"/>
-          <a:chOff x="0" y="0"/>
-          <a:chExt cx="0" cy="0"/>
-        </a:xfrm>
-      </p:grpSpPr>
-      <p:sp>
-        <p:nvSpPr>
-          <p:cNvPr id="3075" name="Rectangle 2"/>
-          <p:cNvSpPr>
-            <a:spLocks noGrp="1" noChangeArrowheads="1"/>
-          </p:cNvSpPr>
-          <p:nvPr>
-            <p:ph type="title"/>
-          </p:nvPr>
-        </p:nvSpPr>
-        <p:spPr/>
-        <p:txBody>
-          <a:bodyPr/>
-          <a:lstStyle/>
-          <a:p>
-            <a:pPr eaLnBrk="1" hangingPunct="1"/>
-            <a:r>
-              <a:rPr lang="en-US">
-                <a:latin typeface="Symbol" pitchFamily="18" charset="2"/>
-              </a:rPr>
-              <a:t>D</a:t>
-            </a:r>
-            <a:r>
-              <a:rPr lang="en-US" i="1"/>
-              <a:t>S</a:t>
-            </a:r>
-            <a:r>
-              <a:rPr lang="en-US"/>
-              <a:t> for a Reversible Cycle</a:t>
-            </a:r>
-            <a:endParaRPr lang="en-US">
-              <a:latin typeface="Symbol" pitchFamily="18" charset="2"/>
-            </a:endParaRPr>
-          </a:p>
-        </p:txBody>
-      </p:sp>
-      <p:sp>
-        <p:nvSpPr>
-          <p:cNvPr id="3076" name="Rectangle 3"/>
-          <p:cNvSpPr>
-            <a:spLocks noGrp="1" noChangeArrowheads="1"/>
-          </p:cNvSpPr>
-          <p:nvPr>
-            <p:ph type="body" idx="1"/>
-          </p:nvPr>
-        </p:nvSpPr>
-        <p:spPr/>
-        <p:txBody>
-          <a:bodyPr/>
-          <a:lstStyle/>
-          <a:p>
-            <a:pPr eaLnBrk="1" hangingPunct="1"/>
-            <a:r>
-              <a:rPr lang="en-US">
-                <a:latin typeface="Symbol" pitchFamily="18" charset="2"/>
-              </a:rPr>
-              <a:t>D</a:t>
-            </a:r>
-            <a:r>
-              <a:rPr lang="en-US" i="1"/>
-              <a:t>S</a:t>
-            </a:r>
-            <a:r>
-              <a:rPr lang="en-US"/>
-              <a:t> = 0 for any reversible cycle</a:t>
-            </a:r>
-          </a:p>
-          <a:p>
-            <a:pPr eaLnBrk="1" hangingPunct="1"/>
-            <a:r>
-              <a:rPr lang="en-US"/>
-              <a:t>In general, </a:t>
-            </a:r>
-          </a:p>
-          <a:p>
-            <a:pPr eaLnBrk="1" hangingPunct="1"/>
-            <a:endParaRPr lang="en-US"/>
-          </a:p>
-          <a:p>
-            <a:pPr eaLnBrk="1" hangingPunct="1"/>
-            <a:endParaRPr lang="en-US"/>
-          </a:p>
-          <a:p>
-            <a:pPr lvl="1" eaLnBrk="1" hangingPunct="1"/>
-            <a:r>
-              <a:rPr lang="en-US"/>
-              <a:t>This integral symbol indicates the integral is over a closed path</a:t>
-            </a:r>
-          </a:p>
-        </p:txBody>
-      </p:sp>
-      <p:graphicFrame>
-        <p:nvGraphicFramePr>
-          <p:cNvPr id="3074" name="Object 5"/>
-          <p:cNvGraphicFramePr>
-            <a:graphicFrameLocks noChangeAspect="1"/>
-          </p:cNvGraphicFramePr>
-          <p:nvPr/>
-        </p:nvGraphicFramePr>
-        <p:xfrm>
-          <a:off x="4941888" y="2865439"/>
-          <a:ext cx="1643062" cy="1019175"/>
-        </p:xfrm>
-        <a:graphic>
-          <a:graphicData uri="http://schemas.openxmlformats.org/presentationml/2006/ole">
-            <mc:AlternateContent xmlns:mc="http://schemas.openxmlformats.org/markup-compatibility/2006">
-              <mc:Choice xmlns:v="urn:schemas-microsoft-com:vml" Requires="v">
-                <p:oleObj name="Equation" r:id="rId2" imgW="634680" imgH="393480" progId="Equation.3">
-                  <p:embed/>
-                </p:oleObj>
-              </mc:Choice>
-              <mc:Fallback>
-                <p:oleObj name="Equation" r:id="rId2" imgW="634680" imgH="393480" progId="Equation.3">
-                  <p:embed/>
-                  <p:pic>
-                    <p:nvPicPr>
-                      <p:cNvPr id="3074" name="Object 5"/>
-                      <p:cNvPicPr>
-                        <a:picLocks noChangeAspect="1" noChangeArrowheads="1"/>
-                      </p:cNvPicPr>
-                      <p:nvPr/>
-                    </p:nvPicPr>
-                    <p:blipFill>
-                      <a:blip r:embed="rId3">
-                        <a:extLst>
-                          <a:ext uri="{28A0092B-C50C-407E-A947-70E740481C1C}">
-                            <a14:useLocalDpi xmlns:a14="http://schemas.microsoft.com/office/drawing/2010/main" val="0"/>
-                          </a:ext>
-                        </a:extLst>
-                      </a:blip>
-                      <a:srcRect/>
-                      <a:stretch>
-                        <a:fillRect/>
-                      </a:stretch>
-                    </p:blipFill>
-                    <p:spPr bwMode="auto">
-                      <a:xfrm>
-                        <a:off x="4941888" y="2865439"/>
-                        <a:ext cx="1643062" cy="1019175"/>
-                      </a:xfrm>
-                      <a:prstGeom prst="rect">
-                        <a:avLst/>
-                      </a:prstGeom>
-                      <a:noFill/>
-                      <a:extLst>
-                        <a:ext uri="{909E8E84-426E-40DD-AFC4-6F175D3DCCD1}">
-                          <a14:hiddenFill xmlns:a14="http://schemas.microsoft.com/office/drawing/2010/main">
-                            <a:solidFill>
-                              <a:srgbClr val="FFFFFF"/>
-                            </a:solidFill>
-                          </a14:hiddenFill>
-                        </a:ext>
-                      </a:extLst>
-                    </p:spPr>
-                  </p:pic>
-                </p:oleObj>
-              </mc:Fallback>
-            </mc:AlternateContent>
-          </a:graphicData>
-        </a:graphic>
-      </p:graphicFrame>
-    </p:spTree>
-    <p:extLst>
-      <p:ext uri="{BB962C8B-B14F-4D97-AF65-F5344CB8AC3E}">
-        <p14:creationId xmlns:p14="http://schemas.microsoft.com/office/powerpoint/2010/main" val="1735856818"/>
-      </p:ext>
-    </p:extLst>
-  </p:cSld>
-  <p:clrMapOvr>
-    <a:masterClrMapping/>
-  </p:clrMapOvr>
-</p:sld>
-</file>
-
-<file path=ppt/slides/slide2.xml><?xml version="1.0" encoding="utf-8"?>
-<p:sld xmlns:a="http://schemas.openxmlformats.org/drawingml/2006/main" xmlns:r="http://schemas.openxmlformats.org/officeDocument/2006/relationships" xmlns:p="http://schemas.openxmlformats.org/presentationml/2006/main">
-  <p:cSld>
-    <p:spTree>
-      <p:nvGrpSpPr>
-        <p:cNvPr id="1" name=""/>
-        <p:cNvGrpSpPr/>
-        <p:nvPr/>
-      </p:nvGrpSpPr>
-      <p:grpSpPr>
-        <a:xfrm>
-          <a:off x="0" y="0"/>
-          <a:ext cx="0" cy="0"/>
-          <a:chOff x="0" y="0"/>
-          <a:chExt cx="0" cy="0"/>
-        </a:xfrm>
-      </p:grpSpPr>
-      <p:sp>
-        <p:nvSpPr>
-          <p:cNvPr id="2" name="Title 1"/>
-          <p:cNvSpPr>
-            <a:spLocks noGrp="1"/>
-          </p:cNvSpPr>
-          <p:nvPr>
-            <p:ph type="title"/>
-          </p:nvPr>
-        </p:nvSpPr>
-        <p:spPr/>
-        <p:txBody>
-          <a:bodyPr/>
-          <a:lstStyle/>
-          <a:p>
-            <a:r>
-              <a:rPr lang="en-US" dirty="0"/>
-              <a:t>Question 123.16.1</a:t>
-            </a:r>
-          </a:p>
-        </p:txBody>
-      </p:sp>
-      <p:sp>
-        <p:nvSpPr>
-          <p:cNvPr id="3" name="Content Placeholder 2"/>
-          <p:cNvSpPr>
-            <a:spLocks noGrp="1"/>
-          </p:cNvSpPr>
-          <p:nvPr>
-            <p:ph idx="1"/>
-          </p:nvPr>
-        </p:nvSpPr>
-        <p:spPr/>
-        <p:txBody>
-          <a:bodyPr/>
-          <a:lstStyle/>
-          <a:p>
-            <a:pPr>
-              <a:buNone/>
-            </a:pPr>
-            <a:r>
-              <a:rPr lang="en-US" dirty="0"/>
-              <a:t>What is the microscopic mechanism for energy transfer between two objects in thermal contact?</a:t>
-            </a:r>
-          </a:p>
-          <a:p>
-            <a:pPr marL="514350" indent="-514350">
-              <a:buFont typeface="+mj-lt"/>
-              <a:buAutoNum type="alphaLcParenR"/>
-            </a:pPr>
-            <a:r>
-              <a:rPr lang="en-US" dirty="0"/>
-              <a:t>collisions</a:t>
-            </a:r>
-          </a:p>
-          <a:p>
-            <a:pPr marL="514350" indent="-514350">
-              <a:buFont typeface="+mj-lt"/>
-              <a:buAutoNum type="alphaLcParenR"/>
-            </a:pPr>
-            <a:r>
-              <a:rPr lang="en-US" dirty="0"/>
-              <a:t>Heat moving</a:t>
-            </a:r>
-          </a:p>
-          <a:p>
-            <a:pPr marL="514350" indent="-514350">
-              <a:buFont typeface="+mj-lt"/>
-              <a:buAutoNum type="alphaLcParenR"/>
-            </a:pPr>
-            <a:r>
-              <a:rPr lang="en-US" dirty="0"/>
-              <a:t>Transfer of particles</a:t>
-            </a:r>
-          </a:p>
-          <a:p>
-            <a:pPr marL="514350" indent="-514350">
-              <a:buFont typeface="+mj-lt"/>
-              <a:buAutoNum type="alphaLcParenR"/>
-            </a:pPr>
-            <a:r>
-              <a:rPr lang="en-US" dirty="0"/>
-              <a:t>Radiation</a:t>
-            </a:r>
-          </a:p>
-          <a:p>
-            <a:pPr marL="514350" indent="-514350">
-              <a:buFont typeface="+mj-lt"/>
-              <a:buAutoNum type="alphaLcParenR"/>
-            </a:pPr>
-            <a:endParaRPr lang="en-US" dirty="0"/>
-          </a:p>
-        </p:txBody>
-      </p:sp>
-      <p:sp>
-        <p:nvSpPr>
-          <p:cNvPr id="4" name="Slide Number Placeholder 3"/>
-          <p:cNvSpPr>
-            <a:spLocks noGrp="1"/>
-          </p:cNvSpPr>
-          <p:nvPr>
-            <p:ph type="sldNum" sz="quarter" idx="12"/>
-          </p:nvPr>
-        </p:nvSpPr>
-        <p:spPr/>
-        <p:txBody>
-          <a:bodyPr/>
-          <a:lstStyle/>
-          <a:p>
-            <a:pPr>
-              <a:defRPr/>
-            </a:pPr>
-            <a:fld id="{4E87D1FB-7ED3-4D53-B026-4508F19EE3B8}" type="slidenum">
-              <a:rPr lang="en-US" smtClean="0"/>
-              <a:pPr>
-                <a:defRPr/>
-              </a:pPr>
-              <a:t>2</a:t>
-            </a:fld>
-            <a:endParaRPr lang="en-US"/>
-          </a:p>
-        </p:txBody>
-      </p:sp>
-    </p:spTree>
-    <p:extLst>
-      <p:ext uri="{BB962C8B-B14F-4D97-AF65-F5344CB8AC3E}">
-        <p14:creationId xmlns:p14="http://schemas.microsoft.com/office/powerpoint/2010/main" val="3204804901"/>
-      </p:ext>
-    </p:extLst>
-  </p:cSld>
-  <p:clrMapOvr>
-    <a:masterClrMapping/>
-  </p:clrMapOvr>
-</p:sld>
-</file>
-
-<file path=ppt/slides/slide20.xml><?xml version="1.0" encoding="utf-8"?>
-<p:sld xmlns:a="http://schemas.openxmlformats.org/drawingml/2006/main" xmlns:r="http://schemas.openxmlformats.org/officeDocument/2006/relationships" xmlns:p="http://schemas.openxmlformats.org/presentationml/2006/main">
-  <p:cSld>
-    <p:spTree>
-      <p:nvGrpSpPr>
-        <p:cNvPr id="1" name=""/>
-        <p:cNvGrpSpPr/>
-        <p:nvPr/>
-      </p:nvGrpSpPr>
-      <p:grpSpPr>
-        <a:xfrm>
-          <a:off x="0" y="0"/>
-          <a:ext cx="0" cy="0"/>
-          <a:chOff x="0" y="0"/>
-          <a:chExt cx="0" cy="0"/>
-        </a:xfrm>
-      </p:grpSpPr>
-      <p:sp>
-        <p:nvSpPr>
           <p:cNvPr id="4099" name="Rectangle 4"/>
           <p:cNvSpPr>
             <a:spLocks noGrp="1" noChangeArrowheads="1"/>
@@ -5957,7 +5511,7 @@
 </p:sld>
 </file>
 
-<file path=ppt/slides/slide21.xml><?xml version="1.0" encoding="utf-8"?>
+<file path=ppt/slides/slide19.xml><?xml version="1.0" encoding="utf-8"?>
 <p:sld xmlns:a="http://schemas.openxmlformats.org/drawingml/2006/main" xmlns:r="http://schemas.openxmlformats.org/officeDocument/2006/relationships" xmlns:p="http://schemas.openxmlformats.org/presentationml/2006/main">
   <p:cSld>
     <p:spTree>
@@ -6113,7 +5667,160 @@
 </p:sld>
 </file>
 
-<file path=ppt/slides/slide22.xml><?xml version="1.0" encoding="utf-8"?>
+<file path=ppt/slides/slide2.xml><?xml version="1.0" encoding="utf-8"?>
+<p:sld xmlns:a="http://schemas.openxmlformats.org/drawingml/2006/main" xmlns:r="http://schemas.openxmlformats.org/officeDocument/2006/relationships" xmlns:p="http://schemas.openxmlformats.org/presentationml/2006/main">
+  <p:cSld>
+    <p:spTree>
+      <p:nvGrpSpPr>
+        <p:cNvPr id="1" name=""/>
+        <p:cNvGrpSpPr/>
+        <p:nvPr/>
+      </p:nvGrpSpPr>
+      <p:grpSpPr>
+        <a:xfrm>
+          <a:off x="0" y="0"/>
+          <a:ext cx="0" cy="0"/>
+          <a:chOff x="0" y="0"/>
+          <a:chExt cx="0" cy="0"/>
+        </a:xfrm>
+      </p:grpSpPr>
+      <p:sp>
+        <p:nvSpPr>
+          <p:cNvPr id="2" name="Title 1"/>
+          <p:cNvSpPr>
+            <a:spLocks noGrp="1"/>
+          </p:cNvSpPr>
+          <p:nvPr>
+            <p:ph type="title"/>
+          </p:nvPr>
+        </p:nvSpPr>
+        <p:spPr/>
+        <p:txBody>
+          <a:bodyPr/>
+          <a:lstStyle/>
+          <a:p>
+            <a:r>
+              <a:rPr lang="en-US" dirty="0"/>
+              <a:t>Question 123.16.1</a:t>
+            </a:r>
+          </a:p>
+        </p:txBody>
+      </p:sp>
+      <p:sp>
+        <p:nvSpPr>
+          <p:cNvPr id="3" name="Content Placeholder 2"/>
+          <p:cNvSpPr>
+            <a:spLocks noGrp="1"/>
+          </p:cNvSpPr>
+          <p:nvPr>
+            <p:ph idx="1"/>
+          </p:nvPr>
+        </p:nvSpPr>
+        <p:spPr/>
+        <p:txBody>
+          <a:bodyPr/>
+          <a:lstStyle/>
+          <a:p>
+            <a:pPr>
+              <a:buNone/>
+            </a:pPr>
+            <a:r>
+              <a:rPr lang="en-US" dirty="0"/>
+              <a:t>What is the microscopic mechanism for energy transfer between two objects in thermal contact?</a:t>
+            </a:r>
+          </a:p>
+          <a:p>
+            <a:pPr marL="514350" indent="-514350">
+              <a:buFont typeface="+mj-lt"/>
+              <a:buAutoNum type="alphaLcParenR"/>
+            </a:pPr>
+            <a:r>
+              <a:rPr lang="en-US" dirty="0"/>
+              <a:t>collisions</a:t>
+            </a:r>
+          </a:p>
+          <a:p>
+            <a:pPr marL="514350" indent="-514350">
+              <a:buFont typeface="+mj-lt"/>
+              <a:buAutoNum type="alphaLcParenR"/>
+            </a:pPr>
+            <a:r>
+              <a:rPr lang="en-US" dirty="0"/>
+              <a:t>Heat moving</a:t>
+            </a:r>
+          </a:p>
+          <a:p>
+            <a:pPr marL="514350" indent="-514350">
+              <a:buFont typeface="+mj-lt"/>
+              <a:buAutoNum type="alphaLcParenR"/>
+            </a:pPr>
+            <a:r>
+              <a:rPr lang="en-US" dirty="0"/>
+              <a:t>Transfer of particles</a:t>
+            </a:r>
+          </a:p>
+          <a:p>
+            <a:pPr marL="514350" indent="-514350">
+              <a:buFont typeface="+mj-lt"/>
+              <a:buAutoNum type="alphaLcParenR"/>
+            </a:pPr>
+            <a:r>
+              <a:rPr lang="en-US" dirty="0"/>
+              <a:t>Radiation</a:t>
+            </a:r>
+          </a:p>
+          <a:p>
+            <a:pPr marL="514350" indent="-514350">
+              <a:buFont typeface="+mj-lt"/>
+              <a:buAutoNum type="alphaLcParenR"/>
+            </a:pPr>
+            <a:endParaRPr lang="en-US" dirty="0"/>
+          </a:p>
+        </p:txBody>
+      </p:sp>
+      <p:sp>
+        <p:nvSpPr>
+          <p:cNvPr id="4" name="Slide Number Placeholder 3"/>
+          <p:cNvSpPr>
+            <a:spLocks noGrp="1"/>
+          </p:cNvSpPr>
+          <p:nvPr>
+            <p:ph type="sldNum" sz="quarter" idx="12"/>
+          </p:nvPr>
+        </p:nvSpPr>
+        <p:spPr/>
+        <p:txBody>
+          <a:bodyPr/>
+          <a:lstStyle/>
+          <a:p>
+            <a:pPr>
+              <a:defRPr/>
+            </a:pPr>
+            <a:fld id="{4E87D1FB-7ED3-4D53-B026-4508F19EE3B8}" type="slidenum">
+              <a:rPr lang="en-US" smtClean="0"/>
+              <a:pPr>
+                <a:defRPr/>
+              </a:pPr>
+              <a:t>2</a:t>
+            </a:fld>
+            <a:endParaRPr lang="en-US"/>
+          </a:p>
+        </p:txBody>
+      </p:sp>
+    </p:spTree>
+    <p:extLst>
+      <p:ext uri="{BB962C8B-B14F-4D97-AF65-F5344CB8AC3E}">
+        <p14:creationId xmlns:p14="http://schemas.microsoft.com/office/powerpoint/2010/main" val="3204804901"/>
+      </p:ext>
+    </p:extLst>
+  </p:cSld>
+  <p:clrMapOvr>
+    <a:masterClrMapping/>
+  </p:clrMapOvr>
+</p:sld>
+</file>
+
+<file path=ppt/slides/slide20.xml><?xml version="1.0" encoding="utf-8"?>
 <p:sld xmlns:a="http://schemas.openxmlformats.org/drawingml/2006/main" xmlns:r="http://schemas.openxmlformats.org/officeDocument/2006/relationships" xmlns:p="http://schemas.openxmlformats.org/presentationml/2006/main">
   <p:cSld>
     <p:spTree>
@@ -6208,7 +5915,7 @@
 </p:sld>
 </file>
 
-<file path=ppt/slides/slide23.xml><?xml version="1.0" encoding="utf-8"?>
+<file path=ppt/slides/slide21.xml><?xml version="1.0" encoding="utf-8"?>
 <p:sld xmlns:a="http://schemas.openxmlformats.org/drawingml/2006/main" xmlns:r="http://schemas.openxmlformats.org/officeDocument/2006/relationships" xmlns:p="http://schemas.openxmlformats.org/presentationml/2006/main">
   <p:cSld>
     <p:spTree>
@@ -6315,7 +6022,7 @@
 </p:sld>
 </file>
 
-<file path=ppt/slides/slide24.xml><?xml version="1.0" encoding="utf-8"?>
+<file path=ppt/slides/slide22.xml><?xml version="1.0" encoding="utf-8"?>
 <p:sld xmlns:a="http://schemas.openxmlformats.org/drawingml/2006/main" xmlns:r="http://schemas.openxmlformats.org/officeDocument/2006/relationships" xmlns:p="http://schemas.openxmlformats.org/presentationml/2006/main">
   <p:cSld>
     <p:spTree>
@@ -6419,7 +6126,7 @@
 </p:sld>
 </file>
 
-<file path=ppt/slides/slide25.xml><?xml version="1.0" encoding="utf-8"?>
+<file path=ppt/slides/slide23.xml><?xml version="1.0" encoding="utf-8"?>
 <p:sld xmlns:a="http://schemas.openxmlformats.org/drawingml/2006/main" xmlns:r="http://schemas.openxmlformats.org/officeDocument/2006/relationships" xmlns:p="http://schemas.openxmlformats.org/presentationml/2006/main">
   <p:cSld>
     <p:spTree>
@@ -6654,7 +6361,7 @@
 </p:sld>
 </file>
 
-<file path=ppt/slides/slide26.xml><?xml version="1.0" encoding="utf-8"?>
+<file path=ppt/slides/slide24.xml><?xml version="1.0" encoding="utf-8"?>
 <p:sld xmlns:a="http://schemas.openxmlformats.org/drawingml/2006/main" xmlns:r="http://schemas.openxmlformats.org/officeDocument/2006/relationships" xmlns:p="http://schemas.openxmlformats.org/presentationml/2006/main">
   <p:cSld>
     <p:spTree>
@@ -6840,7 +6547,7 @@
 </p:sld>
 </file>
 
-<file path=ppt/slides/slide27.xml><?xml version="1.0" encoding="utf-8"?>
+<file path=ppt/slides/slide25.xml><?xml version="1.0" encoding="utf-8"?>
 <p:sld xmlns:a="http://schemas.openxmlformats.org/drawingml/2006/main" xmlns:r="http://schemas.openxmlformats.org/officeDocument/2006/relationships" xmlns:p="http://schemas.openxmlformats.org/presentationml/2006/main">
   <p:cSld>
     <p:spTree>
@@ -7076,7 +6783,7 @@
 </p:sld>
 </file>
 
-<file path=ppt/slides/slide28.xml><?xml version="1.0" encoding="utf-8"?>
+<file path=ppt/slides/slide26.xml><?xml version="1.0" encoding="utf-8"?>
 <p:sld xmlns:a="http://schemas.openxmlformats.org/drawingml/2006/main" xmlns:r="http://schemas.openxmlformats.org/officeDocument/2006/relationships" xmlns:p="http://schemas.openxmlformats.org/presentationml/2006/main">
   <p:cSld>
     <p:spTree>
@@ -7297,7 +7004,7 @@
 </p:sld>
 </file>
 
-<file path=ppt/slides/slide29.xml><?xml version="1.0" encoding="utf-8"?>
+<file path=ppt/slides/slide27.xml><?xml version="1.0" encoding="utf-8"?>
 <p:sld xmlns:a="http://schemas.openxmlformats.org/drawingml/2006/main" xmlns:r="http://schemas.openxmlformats.org/officeDocument/2006/relationships" xmlns:p="http://schemas.openxmlformats.org/presentationml/2006/main">
   <p:cSld>
     <p:spTree>
@@ -7334,7 +7041,7 @@
             <a:fld id="{C8DC7579-8A71-4CF2-8C80-54DAA6C21BFA}" type="slidenum">
               <a:rPr lang="en-US" smtClean="0"/>
               <a:pPr/>
-              <a:t>29</a:t>
+              <a:t>27</a:t>
             </a:fld>
             <a:endParaRPr lang="en-US"/>
           </a:p>
@@ -7456,6 +7163,258 @@
         <p14:creationId xmlns:p14="http://schemas.microsoft.com/office/powerpoint/2010/main" val="4053757444"/>
       </p:ext>
     </p:extLst>
+  </p:cSld>
+  <p:clrMapOvr>
+    <a:masterClrMapping/>
+  </p:clrMapOvr>
+</p:sld>
+</file>
+
+<file path=ppt/slides/slide28.xml><?xml version="1.0" encoding="utf-8"?>
+<p:sld xmlns:a="http://schemas.openxmlformats.org/drawingml/2006/main" xmlns:r="http://schemas.openxmlformats.org/officeDocument/2006/relationships" xmlns:p="http://schemas.openxmlformats.org/presentationml/2006/main">
+  <p:cSld>
+    <p:spTree>
+      <p:nvGrpSpPr>
+        <p:cNvPr id="1" name=""/>
+        <p:cNvGrpSpPr/>
+        <p:nvPr/>
+      </p:nvGrpSpPr>
+      <p:grpSpPr>
+        <a:xfrm>
+          <a:off x="0" y="0"/>
+          <a:ext cx="0" cy="0"/>
+          <a:chOff x="0" y="0"/>
+          <a:chExt cx="0" cy="0"/>
+        </a:xfrm>
+      </p:grpSpPr>
+      <p:sp>
+        <p:nvSpPr>
+          <p:cNvPr id="185346" name="Slide Number Placeholder 5"/>
+          <p:cNvSpPr>
+            <a:spLocks noGrp="1"/>
+          </p:cNvSpPr>
+          <p:nvPr>
+            <p:ph type="sldNum" sz="quarter" idx="12"/>
+          </p:nvPr>
+        </p:nvSpPr>
+        <p:spPr>
+          <a:noFill/>
+        </p:spPr>
+        <p:txBody>
+          <a:bodyPr/>
+          <a:lstStyle/>
+          <a:p>
+            <a:fld id="{230DFF15-7384-41A0-9FCD-D051FFD3566A}" type="slidenum">
+              <a:rPr lang="en-US" smtClean="0"/>
+              <a:pPr/>
+              <a:t>28</a:t>
+            </a:fld>
+            <a:endParaRPr lang="en-US"/>
+          </a:p>
+        </p:txBody>
+      </p:sp>
+      <p:sp>
+        <p:nvSpPr>
+          <p:cNvPr id="185347" name="Rectangle 2"/>
+          <p:cNvSpPr>
+            <a:spLocks noGrp="1" noChangeArrowheads="1"/>
+          </p:cNvSpPr>
+          <p:nvPr>
+            <p:ph type="title"/>
+          </p:nvPr>
+        </p:nvSpPr>
+        <p:spPr/>
+        <p:txBody>
+          <a:bodyPr/>
+          <a:lstStyle/>
+          <a:p>
+            <a:pPr eaLnBrk="1" hangingPunct="1"/>
+            <a:r>
+              <a:rPr lang="en-US"/>
+              <a:t>Question 20.8</a:t>
+            </a:r>
+          </a:p>
+        </p:txBody>
+      </p:sp>
+      <p:sp>
+        <p:nvSpPr>
+          <p:cNvPr id="185348" name="Rectangle 3"/>
+          <p:cNvSpPr>
+            <a:spLocks noGrp="1" noChangeArrowheads="1"/>
+          </p:cNvSpPr>
+          <p:nvPr>
+            <p:ph type="body" idx="1"/>
+          </p:nvPr>
+        </p:nvSpPr>
+        <p:spPr/>
+        <p:txBody>
+          <a:bodyPr/>
+          <a:lstStyle/>
+          <a:p>
+            <a:pPr marL="609600" indent="-609600">
+              <a:buNone/>
+            </a:pPr>
+            <a:r>
+              <a:rPr lang="en-US" dirty="0"/>
+              <a:t>By observing a system we find that</a:t>
+            </a:r>
+          </a:p>
+          <a:p>
+            <a:pPr marL="609600" indent="-609600">
+              <a:buNone/>
+            </a:pPr>
+            <a:r>
+              <a:rPr lang="en-US" dirty="0"/>
+              <a:t>                   </a:t>
+            </a:r>
+            <a:r>
+              <a:rPr lang="en-US" dirty="0">
+                <a:sym typeface="Symbol" pitchFamily="18" charset="2"/>
+              </a:rPr>
+              <a:t></a:t>
+            </a:r>
+            <a:r>
+              <a:rPr lang="en-US" dirty="0" err="1"/>
+              <a:t>E</a:t>
+            </a:r>
+            <a:r>
+              <a:rPr lang="en-US" baseline="-25000" dirty="0" err="1"/>
+              <a:t>int</a:t>
+            </a:r>
+            <a:r>
+              <a:rPr lang="en-US" baseline="-25000" dirty="0"/>
+              <a:t> </a:t>
+            </a:r>
+            <a:r>
+              <a:rPr lang="en-US" dirty="0"/>
+              <a:t>= 0</a:t>
+            </a:r>
+          </a:p>
+          <a:p>
+            <a:pPr marL="609600" indent="-609600">
+              <a:buNone/>
+            </a:pPr>
+            <a:r>
+              <a:rPr lang="en-US" dirty="0"/>
+              <a:t>What might be the reason for this?</a:t>
+            </a:r>
+          </a:p>
+          <a:p>
+            <a:pPr marL="609600" indent="-609600">
+              <a:buFontTx/>
+              <a:buAutoNum type="alphaLcParenR"/>
+            </a:pPr>
+            <a:r>
+              <a:rPr lang="en-US" dirty="0"/>
+              <a:t>It is isolated</a:t>
+            </a:r>
+          </a:p>
+          <a:p>
+            <a:pPr marL="609600" indent="-609600">
+              <a:buFontTx/>
+              <a:buAutoNum type="alphaLcParenR"/>
+            </a:pPr>
+            <a:r>
+              <a:rPr lang="en-US" dirty="0"/>
+              <a:t>It is cyclic</a:t>
+            </a:r>
+          </a:p>
+          <a:p>
+            <a:pPr marL="609600" indent="-609600">
+              <a:buFontTx/>
+              <a:buAutoNum type="alphaLcParenR"/>
+            </a:pPr>
+            <a:r>
+              <a:rPr lang="en-US" dirty="0"/>
+              <a:t>It is isobaric</a:t>
+            </a:r>
+          </a:p>
+          <a:p>
+            <a:pPr marL="609600" indent="-609600">
+              <a:buFontTx/>
+              <a:buAutoNum type="alphaLcParenR"/>
+            </a:pPr>
+            <a:r>
+              <a:rPr lang="en-US" dirty="0"/>
+              <a:t>Can’t tell</a:t>
+            </a:r>
+          </a:p>
+        </p:txBody>
+      </p:sp>
+    </p:spTree>
+    <p:extLst>
+      <p:ext uri="{BB962C8B-B14F-4D97-AF65-F5344CB8AC3E}">
+        <p14:creationId xmlns:p14="http://schemas.microsoft.com/office/powerpoint/2010/main" val="3055023919"/>
+      </p:ext>
+    </p:extLst>
+  </p:cSld>
+  <p:clrMapOvr>
+    <a:masterClrMapping/>
+  </p:clrMapOvr>
+</p:sld>
+</file>
+
+<file path=ppt/slides/slide29.xml><?xml version="1.0" encoding="utf-8"?>
+<p:sld xmlns:a="http://schemas.openxmlformats.org/drawingml/2006/main" xmlns:r="http://schemas.openxmlformats.org/officeDocument/2006/relationships" xmlns:p="http://schemas.openxmlformats.org/presentationml/2006/main">
+  <p:cSld>
+    <p:spTree>
+      <p:nvGrpSpPr>
+        <p:cNvPr id="1" name=""/>
+        <p:cNvGrpSpPr/>
+        <p:nvPr/>
+      </p:nvGrpSpPr>
+      <p:grpSpPr>
+        <a:xfrm>
+          <a:off x="0" y="0"/>
+          <a:ext cx="0" cy="0"/>
+          <a:chOff x="0" y="0"/>
+          <a:chExt cx="0" cy="0"/>
+        </a:xfrm>
+      </p:grpSpPr>
+      <p:sp>
+        <p:nvSpPr>
+          <p:cNvPr id="2050" name="Rectangle 2"/>
+          <p:cNvSpPr>
+            <a:spLocks noGrp="1" noChangeArrowheads="1"/>
+          </p:cNvSpPr>
+          <p:nvPr>
+            <p:ph type="ctrTitle"/>
+          </p:nvPr>
+        </p:nvSpPr>
+        <p:spPr/>
+        <p:txBody>
+          <a:bodyPr>
+            <a:normAutofit/>
+          </a:bodyPr>
+          <a:lstStyle/>
+          <a:p>
+            <a:r>
+              <a:rPr lang="en-US" sz="4000"/>
+              <a:t>An Opinion on the Second Law of Thermodynamics and Mormon Thought</a:t>
+            </a:r>
+          </a:p>
+        </p:txBody>
+      </p:sp>
+      <p:sp>
+        <p:nvSpPr>
+          <p:cNvPr id="2051" name="Rectangle 3"/>
+          <p:cNvSpPr>
+            <a:spLocks noGrp="1" noChangeArrowheads="1"/>
+          </p:cNvSpPr>
+          <p:nvPr>
+            <p:ph type="subTitle" idx="1"/>
+          </p:nvPr>
+        </p:nvSpPr>
+        <p:spPr/>
+        <p:txBody>
+          <a:bodyPr/>
+          <a:lstStyle/>
+          <a:p>
+            <a:endParaRPr lang="en-US"/>
+          </a:p>
+        </p:txBody>
+      </p:sp>
+    </p:spTree>
   </p:cSld>
   <p:clrMapOvr>
     <a:masterClrMapping/>
@@ -7623,258 +7582,6 @@
       </p:grpSpPr>
       <p:sp>
         <p:nvSpPr>
-          <p:cNvPr id="185346" name="Slide Number Placeholder 5"/>
-          <p:cNvSpPr>
-            <a:spLocks noGrp="1"/>
-          </p:cNvSpPr>
-          <p:nvPr>
-            <p:ph type="sldNum" sz="quarter" idx="12"/>
-          </p:nvPr>
-        </p:nvSpPr>
-        <p:spPr>
-          <a:noFill/>
-        </p:spPr>
-        <p:txBody>
-          <a:bodyPr/>
-          <a:lstStyle/>
-          <a:p>
-            <a:fld id="{230DFF15-7384-41A0-9FCD-D051FFD3566A}" type="slidenum">
-              <a:rPr lang="en-US" smtClean="0"/>
-              <a:pPr/>
-              <a:t>30</a:t>
-            </a:fld>
-            <a:endParaRPr lang="en-US"/>
-          </a:p>
-        </p:txBody>
-      </p:sp>
-      <p:sp>
-        <p:nvSpPr>
-          <p:cNvPr id="185347" name="Rectangle 2"/>
-          <p:cNvSpPr>
-            <a:spLocks noGrp="1" noChangeArrowheads="1"/>
-          </p:cNvSpPr>
-          <p:nvPr>
-            <p:ph type="title"/>
-          </p:nvPr>
-        </p:nvSpPr>
-        <p:spPr/>
-        <p:txBody>
-          <a:bodyPr/>
-          <a:lstStyle/>
-          <a:p>
-            <a:pPr eaLnBrk="1" hangingPunct="1"/>
-            <a:r>
-              <a:rPr lang="en-US"/>
-              <a:t>Question 20.8</a:t>
-            </a:r>
-          </a:p>
-        </p:txBody>
-      </p:sp>
-      <p:sp>
-        <p:nvSpPr>
-          <p:cNvPr id="185348" name="Rectangle 3"/>
-          <p:cNvSpPr>
-            <a:spLocks noGrp="1" noChangeArrowheads="1"/>
-          </p:cNvSpPr>
-          <p:nvPr>
-            <p:ph type="body" idx="1"/>
-          </p:nvPr>
-        </p:nvSpPr>
-        <p:spPr/>
-        <p:txBody>
-          <a:bodyPr/>
-          <a:lstStyle/>
-          <a:p>
-            <a:pPr marL="609600" indent="-609600">
-              <a:buNone/>
-            </a:pPr>
-            <a:r>
-              <a:rPr lang="en-US" dirty="0"/>
-              <a:t>By observing a system we find that</a:t>
-            </a:r>
-          </a:p>
-          <a:p>
-            <a:pPr marL="609600" indent="-609600">
-              <a:buNone/>
-            </a:pPr>
-            <a:r>
-              <a:rPr lang="en-US" dirty="0"/>
-              <a:t>                   </a:t>
-            </a:r>
-            <a:r>
-              <a:rPr lang="en-US" dirty="0">
-                <a:sym typeface="Symbol" pitchFamily="18" charset="2"/>
-              </a:rPr>
-              <a:t></a:t>
-            </a:r>
-            <a:r>
-              <a:rPr lang="en-US" dirty="0" err="1"/>
-              <a:t>E</a:t>
-            </a:r>
-            <a:r>
-              <a:rPr lang="en-US" baseline="-25000" dirty="0" err="1"/>
-              <a:t>int</a:t>
-            </a:r>
-            <a:r>
-              <a:rPr lang="en-US" baseline="-25000" dirty="0"/>
-              <a:t> </a:t>
-            </a:r>
-            <a:r>
-              <a:rPr lang="en-US" dirty="0"/>
-              <a:t>= 0</a:t>
-            </a:r>
-          </a:p>
-          <a:p>
-            <a:pPr marL="609600" indent="-609600">
-              <a:buNone/>
-            </a:pPr>
-            <a:r>
-              <a:rPr lang="en-US" dirty="0"/>
-              <a:t>What might be the reason for this?</a:t>
-            </a:r>
-          </a:p>
-          <a:p>
-            <a:pPr marL="609600" indent="-609600">
-              <a:buFontTx/>
-              <a:buAutoNum type="alphaLcParenR"/>
-            </a:pPr>
-            <a:r>
-              <a:rPr lang="en-US" dirty="0"/>
-              <a:t>It is isolated</a:t>
-            </a:r>
-          </a:p>
-          <a:p>
-            <a:pPr marL="609600" indent="-609600">
-              <a:buFontTx/>
-              <a:buAutoNum type="alphaLcParenR"/>
-            </a:pPr>
-            <a:r>
-              <a:rPr lang="en-US" dirty="0"/>
-              <a:t>It is cyclic</a:t>
-            </a:r>
-          </a:p>
-          <a:p>
-            <a:pPr marL="609600" indent="-609600">
-              <a:buFontTx/>
-              <a:buAutoNum type="alphaLcParenR"/>
-            </a:pPr>
-            <a:r>
-              <a:rPr lang="en-US" dirty="0"/>
-              <a:t>It is isobaric</a:t>
-            </a:r>
-          </a:p>
-          <a:p>
-            <a:pPr marL="609600" indent="-609600">
-              <a:buFontTx/>
-              <a:buAutoNum type="alphaLcParenR"/>
-            </a:pPr>
-            <a:r>
-              <a:rPr lang="en-US" dirty="0"/>
-              <a:t>Can’t tell</a:t>
-            </a:r>
-          </a:p>
-        </p:txBody>
-      </p:sp>
-    </p:spTree>
-    <p:extLst>
-      <p:ext uri="{BB962C8B-B14F-4D97-AF65-F5344CB8AC3E}">
-        <p14:creationId xmlns:p14="http://schemas.microsoft.com/office/powerpoint/2010/main" val="3055023919"/>
-      </p:ext>
-    </p:extLst>
-  </p:cSld>
-  <p:clrMapOvr>
-    <a:masterClrMapping/>
-  </p:clrMapOvr>
-</p:sld>
-</file>
-
-<file path=ppt/slides/slide31.xml><?xml version="1.0" encoding="utf-8"?>
-<p:sld xmlns:a="http://schemas.openxmlformats.org/drawingml/2006/main" xmlns:r="http://schemas.openxmlformats.org/officeDocument/2006/relationships" xmlns:p="http://schemas.openxmlformats.org/presentationml/2006/main">
-  <p:cSld>
-    <p:spTree>
-      <p:nvGrpSpPr>
-        <p:cNvPr id="1" name=""/>
-        <p:cNvGrpSpPr/>
-        <p:nvPr/>
-      </p:nvGrpSpPr>
-      <p:grpSpPr>
-        <a:xfrm>
-          <a:off x="0" y="0"/>
-          <a:ext cx="0" cy="0"/>
-          <a:chOff x="0" y="0"/>
-          <a:chExt cx="0" cy="0"/>
-        </a:xfrm>
-      </p:grpSpPr>
-      <p:sp>
-        <p:nvSpPr>
-          <p:cNvPr id="2050" name="Rectangle 2"/>
-          <p:cNvSpPr>
-            <a:spLocks noGrp="1" noChangeArrowheads="1"/>
-          </p:cNvSpPr>
-          <p:nvPr>
-            <p:ph type="ctrTitle"/>
-          </p:nvPr>
-        </p:nvSpPr>
-        <p:spPr/>
-        <p:txBody>
-          <a:bodyPr>
-            <a:normAutofit/>
-          </a:bodyPr>
-          <a:lstStyle/>
-          <a:p>
-            <a:r>
-              <a:rPr lang="en-US" sz="4000"/>
-              <a:t>An Opinion on the Second Law of Thermodynamics and Mormon Thought</a:t>
-            </a:r>
-          </a:p>
-        </p:txBody>
-      </p:sp>
-      <p:sp>
-        <p:nvSpPr>
-          <p:cNvPr id="2051" name="Rectangle 3"/>
-          <p:cNvSpPr>
-            <a:spLocks noGrp="1" noChangeArrowheads="1"/>
-          </p:cNvSpPr>
-          <p:nvPr>
-            <p:ph type="subTitle" idx="1"/>
-          </p:nvPr>
-        </p:nvSpPr>
-        <p:spPr/>
-        <p:txBody>
-          <a:bodyPr/>
-          <a:lstStyle/>
-          <a:p>
-            <a:endParaRPr lang="en-US"/>
-          </a:p>
-        </p:txBody>
-      </p:sp>
-    </p:spTree>
-  </p:cSld>
-  <p:clrMapOvr>
-    <a:masterClrMapping/>
-  </p:clrMapOvr>
-</p:sld>
-</file>
-
-<file path=ppt/slides/slide32.xml><?xml version="1.0" encoding="utf-8"?>
-<p:sld xmlns:a="http://schemas.openxmlformats.org/drawingml/2006/main" xmlns:r="http://schemas.openxmlformats.org/officeDocument/2006/relationships" xmlns:p="http://schemas.openxmlformats.org/presentationml/2006/main">
-  <p:cSld>
-    <p:spTree>
-      <p:nvGrpSpPr>
-        <p:cNvPr id="1" name=""/>
-        <p:cNvGrpSpPr/>
-        <p:nvPr/>
-      </p:nvGrpSpPr>
-      <p:grpSpPr>
-        <a:xfrm>
-          <a:off x="0" y="0"/>
-          <a:ext cx="0" cy="0"/>
-          <a:chOff x="0" y="0"/>
-          <a:chExt cx="0" cy="0"/>
-        </a:xfrm>
-      </p:grpSpPr>
-      <p:sp>
-        <p:nvSpPr>
           <p:cNvPr id="5122" name="Rectangle 2"/>
           <p:cNvSpPr>
             <a:spLocks noGrp="1" noChangeArrowheads="1"/>
@@ -7938,7 +7645,7 @@
 </p:sld>
 </file>
 
-<file path=ppt/slides/slide33.xml><?xml version="1.0" encoding="utf-8"?>
+<file path=ppt/slides/slide31.xml><?xml version="1.0" encoding="utf-8"?>
 <p:sld xmlns:a="http://schemas.openxmlformats.org/drawingml/2006/main" xmlns:r="http://schemas.openxmlformats.org/officeDocument/2006/relationships" xmlns:p="http://schemas.openxmlformats.org/presentationml/2006/main">
   <p:cSld>
     <p:spTree>
@@ -8105,7 +7812,11 @@
           <a:p>
             <a:pPr algn="ctr"/>
             <a:r>
-              <a:rPr lang="en-US"/>
+              <a:rPr lang="en-US" dirty="0">
+                <a:solidFill>
+                  <a:schemeClr val="bg1"/>
+                </a:solidFill>
+              </a:rPr>
               <a:t>The idea of the first law of thermodynamics seems in harmony with LDS thought</a:t>
             </a:r>
           </a:p>
@@ -8119,7 +7830,7 @@
 </p:sld>
 </file>
 
-<file path=ppt/slides/slide34.xml><?xml version="1.0" encoding="utf-8"?>
+<file path=ppt/slides/slide32.xml><?xml version="1.0" encoding="utf-8"?>
 <p:sld xmlns:a="http://schemas.openxmlformats.org/drawingml/2006/main" xmlns:r="http://schemas.openxmlformats.org/officeDocument/2006/relationships" xmlns:p="http://schemas.openxmlformats.org/presentationml/2006/main">
   <p:cSld>
     <p:spTree>
@@ -8264,15 +7975,27 @@
               </a:spcBef>
             </a:pPr>
             <a:r>
-              <a:rPr lang="en-US"/>
+              <a:rPr lang="en-US" dirty="0">
+                <a:solidFill>
+                  <a:schemeClr val="bg1"/>
+                </a:solidFill>
+              </a:rPr>
               <a:t>We </a:t>
             </a:r>
             <a:r>
-              <a:rPr lang="en-US" i="1"/>
+              <a:rPr lang="en-US" i="1" dirty="0">
+                <a:solidFill>
+                  <a:schemeClr val="bg1"/>
+                </a:solidFill>
+              </a:rPr>
               <a:t>also</a:t>
             </a:r>
             <a:r>
-              <a:rPr lang="en-US"/>
+              <a:rPr lang="en-US" dirty="0">
+                <a:solidFill>
+                  <a:schemeClr val="bg1"/>
+                </a:solidFill>
+              </a:rPr>
               <a:t> seem to accept the concept of the second law as well</a:t>
             </a:r>
           </a:p>
@@ -8286,7 +8009,11 @@
               </a:spcBef>
             </a:pPr>
             <a:r>
-              <a:rPr lang="en-US"/>
+              <a:rPr lang="en-US" dirty="0">
+                <a:solidFill>
+                  <a:schemeClr val="bg1"/>
+                </a:solidFill>
+              </a:rPr>
               <a:t>--This will be a surprise to our non-Mormon friends</a:t>
             </a:r>
           </a:p>
@@ -8300,7 +8027,7 @@
 </p:sld>
 </file>
 
-<file path=ppt/slides/slide35.xml><?xml version="1.0" encoding="utf-8"?>
+<file path=ppt/slides/slide33.xml><?xml version="1.0" encoding="utf-8"?>
 <p:sld xmlns:a="http://schemas.openxmlformats.org/drawingml/2006/main" xmlns:r="http://schemas.openxmlformats.org/officeDocument/2006/relationships" xmlns:p="http://schemas.openxmlformats.org/presentationml/2006/main">
   <p:cSld>
     <p:spTree>
@@ -8367,7 +8094,7 @@
               </a:lnSpc>
             </a:pPr>
             <a:r>
-              <a:rPr lang="en-US" sz="2000"/>
+              <a:rPr lang="en-US" sz="2000" dirty="0"/>
               <a:t>Jacob describes another force not recognized by current scientific theory that counteracts this tendency to decay</a:t>
             </a:r>
           </a:p>
@@ -8378,7 +8105,7 @@
               </a:lnSpc>
             </a:pPr>
             <a:r>
-              <a:rPr lang="en-US" sz="1600"/>
+              <a:rPr lang="en-US" sz="1600" dirty="0"/>
               <a:t>Wherefore, it must needs be an infinite atonement—save it should be an infinite atonement this corruption could not put on incorruption. Wherefore, the first judgment which came upon man must needs have remained to an endless duration. And if so, this flesh must have laid down to rot and to crumble to its mother earth, to rise no more. (2 Nephi 9:7-8)</a:t>
             </a:r>
           </a:p>
@@ -8389,8 +8116,16 @@
               </a:lnSpc>
             </a:pPr>
             <a:r>
-              <a:rPr lang="en-US" sz="1600"/>
-              <a:t>O how great the goodness of our God, who prepareth a way for our escape from the grasp of this awful monster; yea, that monster, death and hell, which I call the death of the body, and also the death of the spirit. (2 Nephi 9:10)</a:t>
+              <a:rPr lang="en-US" sz="1600" dirty="0"/>
+              <a:t>O how great the goodness of our God, who </a:t>
+            </a:r>
+            <a:r>
+              <a:rPr lang="en-US" sz="1600" dirty="0" err="1"/>
+              <a:t>prepareth</a:t>
+            </a:r>
+            <a:r>
+              <a:rPr lang="en-US" sz="1600" dirty="0"/>
+              <a:t> a way for our escape from the grasp of this awful monster; yea, that monster, death and hell, which I call the death of the body, and also the death of the spirit. (2 Nephi 9:10)</a:t>
             </a:r>
           </a:p>
           <a:p>
@@ -8400,11 +8135,11 @@
               </a:lnSpc>
             </a:pPr>
             <a:r>
-              <a:rPr lang="en-US" sz="2000"/>
+              <a:rPr lang="en-US" sz="2000" dirty="0"/>
               <a:t>Atonement means to bring together. This is an apt description of a process or law that would counter or balance the second law</a:t>
             </a:r>
             <a:r>
-              <a:rPr lang="en-US" sz="1800"/>
+              <a:rPr lang="en-US" sz="1800" dirty="0"/>
               <a:t> </a:t>
             </a:r>
           </a:p>
@@ -8415,7 +8150,7 @@
               </a:lnSpc>
             </a:pPr>
             <a:r>
-              <a:rPr lang="en-US" sz="1600"/>
+              <a:rPr lang="en-US" sz="1600" dirty="0"/>
               <a:t>(Nibley, The meaning of the temple, reprinted in the Collected Works of Hugh Nibley: volume 12, Deseret Book, Salt Lake City, UT, 1992)</a:t>
             </a:r>
           </a:p>
@@ -8426,7 +8161,7 @@
               </a:lnSpc>
             </a:pPr>
             <a:r>
-              <a:rPr lang="en-US" sz="1800"/>
+              <a:rPr lang="en-US" sz="1800" dirty="0"/>
               <a:t>Since the atonement can only be accessed through Christ, it is not likely to be discovered in a laboratory, but is a very real, physical, process. (see for example Luke 24:39)</a:t>
             </a:r>
           </a:p>
@@ -8436,7 +8171,7 @@
                 <a:spcPct val="80000"/>
               </a:lnSpc>
             </a:pPr>
-            <a:endParaRPr lang="en-US" sz="1800"/>
+            <a:endParaRPr lang="en-US" sz="1800" dirty="0"/>
           </a:p>
           <a:p>
             <a:pPr>
@@ -8444,7 +8179,7 @@
                 <a:spcPct val="80000"/>
               </a:lnSpc>
             </a:pPr>
-            <a:endParaRPr lang="en-US" sz="1800"/>
+            <a:endParaRPr lang="en-US" sz="1800" dirty="0"/>
           </a:p>
         </p:txBody>
       </p:sp>
@@ -8456,7 +8191,7 @@
 </p:sld>
 </file>
 
-<file path=ppt/slides/slide36.xml><?xml version="1.0" encoding="utf-8"?>
+<file path=ppt/slides/slide34.xml><?xml version="1.0" encoding="utf-8"?>
 <p:sld xmlns:a="http://schemas.openxmlformats.org/drawingml/2006/main" xmlns:r="http://schemas.openxmlformats.org/officeDocument/2006/relationships" xmlns:p="http://schemas.openxmlformats.org/presentationml/2006/main">
   <p:cSld>
     <p:spTree>
@@ -8673,149 +8408,6 @@
 </file>
 
 <file path=ppt/slides/slide5.xml><?xml version="1.0" encoding="utf-8"?>
-<p:sld xmlns:a="http://schemas.openxmlformats.org/drawingml/2006/main" xmlns:r="http://schemas.openxmlformats.org/officeDocument/2006/relationships" xmlns:p="http://schemas.openxmlformats.org/presentationml/2006/main">
-  <p:cSld>
-    <p:spTree>
-      <p:nvGrpSpPr>
-        <p:cNvPr id="1" name=""/>
-        <p:cNvGrpSpPr/>
-        <p:nvPr/>
-      </p:nvGrpSpPr>
-      <p:grpSpPr>
-        <a:xfrm>
-          <a:off x="0" y="0"/>
-          <a:ext cx="0" cy="0"/>
-          <a:chOff x="0" y="0"/>
-          <a:chExt cx="0" cy="0"/>
-        </a:xfrm>
-      </p:grpSpPr>
-      <p:sp>
-        <p:nvSpPr>
-          <p:cNvPr id="2" name="Title 1"/>
-          <p:cNvSpPr>
-            <a:spLocks noGrp="1"/>
-          </p:cNvSpPr>
-          <p:nvPr>
-            <p:ph type="title"/>
-          </p:nvPr>
-        </p:nvSpPr>
-        <p:spPr/>
-        <p:txBody>
-          <a:bodyPr/>
-          <a:lstStyle/>
-          <a:p>
-            <a:r>
-              <a:rPr lang="en-US" dirty="0"/>
-              <a:t>Question 123.16.1</a:t>
-            </a:r>
-          </a:p>
-        </p:txBody>
-      </p:sp>
-      <p:sp>
-        <p:nvSpPr>
-          <p:cNvPr id="3" name="Content Placeholder 2"/>
-          <p:cNvSpPr>
-            <a:spLocks noGrp="1"/>
-          </p:cNvSpPr>
-          <p:nvPr>
-            <p:ph idx="1"/>
-          </p:nvPr>
-        </p:nvSpPr>
-        <p:spPr/>
-        <p:txBody>
-          <a:bodyPr/>
-          <a:lstStyle/>
-          <a:p>
-            <a:pPr>
-              <a:buNone/>
-            </a:pPr>
-            <a:r>
-              <a:rPr lang="en-US" dirty="0"/>
-              <a:t>Does disorder always increase in thermodynamic processes?</a:t>
-            </a:r>
-          </a:p>
-          <a:p>
-            <a:pPr marL="514350" indent="-514350">
-              <a:buFont typeface="+mj-lt"/>
-              <a:buAutoNum type="alphaLcParenR"/>
-            </a:pPr>
-            <a:r>
-              <a:rPr lang="en-US" dirty="0"/>
-              <a:t>Yes</a:t>
-            </a:r>
-          </a:p>
-          <a:p>
-            <a:pPr marL="514350" indent="-514350">
-              <a:buFont typeface="+mj-lt"/>
-              <a:buAutoNum type="alphaLcParenR"/>
-            </a:pPr>
-            <a:r>
-              <a:rPr lang="en-US" dirty="0"/>
-              <a:t>No</a:t>
-            </a:r>
-          </a:p>
-          <a:p>
-            <a:pPr marL="514350" indent="-514350">
-              <a:buFont typeface="+mj-lt"/>
-              <a:buAutoNum type="alphaLcParenR"/>
-            </a:pPr>
-            <a:r>
-              <a:rPr lang="en-US" dirty="0"/>
-              <a:t>Maybe (be prepared to explain)</a:t>
-            </a:r>
-          </a:p>
-          <a:p>
-            <a:pPr marL="514350" indent="-514350">
-              <a:buFont typeface="+mj-lt"/>
-              <a:buAutoNum type="alphaLcParenR"/>
-            </a:pPr>
-            <a:endParaRPr lang="en-US" dirty="0"/>
-          </a:p>
-        </p:txBody>
-      </p:sp>
-      <p:sp>
-        <p:nvSpPr>
-          <p:cNvPr id="4" name="Slide Number Placeholder 3"/>
-          <p:cNvSpPr>
-            <a:spLocks noGrp="1"/>
-          </p:cNvSpPr>
-          <p:nvPr>
-            <p:ph type="sldNum" sz="quarter" idx="12"/>
-          </p:nvPr>
-        </p:nvSpPr>
-        <p:spPr/>
-        <p:txBody>
-          <a:bodyPr/>
-          <a:lstStyle/>
-          <a:p>
-            <a:pPr>
-              <a:defRPr/>
-            </a:pPr>
-            <a:fld id="{4E87D1FB-7ED3-4D53-B026-4508F19EE3B8}" type="slidenum">
-              <a:rPr lang="en-US" smtClean="0"/>
-              <a:pPr>
-                <a:defRPr/>
-              </a:pPr>
-              <a:t>5</a:t>
-            </a:fld>
-            <a:endParaRPr lang="en-US"/>
-          </a:p>
-        </p:txBody>
-      </p:sp>
-    </p:spTree>
-    <p:extLst>
-      <p:ext uri="{BB962C8B-B14F-4D97-AF65-F5344CB8AC3E}">
-        <p14:creationId xmlns:p14="http://schemas.microsoft.com/office/powerpoint/2010/main" val="2413419914"/>
-      </p:ext>
-    </p:extLst>
-  </p:cSld>
-  <p:clrMapOvr>
-    <a:masterClrMapping/>
-  </p:clrMapOvr>
-</p:sld>
-</file>
-
-<file path=ppt/slides/slide6.xml><?xml version="1.0" encoding="utf-8"?>
 <p:sld xmlns:a="http://schemas.openxmlformats.org/drawingml/2006/main" xmlns:r="http://schemas.openxmlformats.org/officeDocument/2006/relationships" xmlns:p="http://schemas.openxmlformats.org/presentationml/2006/main">
   <p:cSld>
     <p:spTree>
@@ -9122,7 +8714,7 @@
 </p:sld>
 </file>
 
-<file path=ppt/slides/slide7.xml><?xml version="1.0" encoding="utf-8"?>
+<file path=ppt/slides/slide6.xml><?xml version="1.0" encoding="utf-8"?>
 <p:sld xmlns:a="http://schemas.openxmlformats.org/drawingml/2006/main" xmlns:r="http://schemas.openxmlformats.org/officeDocument/2006/relationships" xmlns:p="http://schemas.openxmlformats.org/presentationml/2006/main">
   <p:cSld>
     <p:spTree>
@@ -9953,7 +9545,7 @@
 </p:sld>
 </file>
 
-<file path=ppt/slides/slide8.xml><?xml version="1.0" encoding="utf-8"?>
+<file path=ppt/slides/slide7.xml><?xml version="1.0" encoding="utf-8"?>
 <p:sld xmlns:a="http://schemas.openxmlformats.org/drawingml/2006/main" xmlns:r="http://schemas.openxmlformats.org/officeDocument/2006/relationships" xmlns:p="http://schemas.openxmlformats.org/presentationml/2006/main">
   <p:cSld>
     <p:spTree>
@@ -12758,7 +12350,7 @@
 </p:sld>
 </file>
 
-<file path=ppt/slides/slide9.xml><?xml version="1.0" encoding="utf-8"?>
+<file path=ppt/slides/slide8.xml><?xml version="1.0" encoding="utf-8"?>
 <p:sld xmlns:a="http://schemas.openxmlformats.org/drawingml/2006/main" xmlns:r="http://schemas.openxmlformats.org/officeDocument/2006/relationships" xmlns:p="http://schemas.openxmlformats.org/presentationml/2006/main">
   <p:cSld>
     <p:spTree>
@@ -20792,6 +20384,149 @@
         </p:sp>
       </p:grpSp>
     </p:spTree>
+  </p:cSld>
+  <p:clrMapOvr>
+    <a:masterClrMapping/>
+  </p:clrMapOvr>
+</p:sld>
+</file>
+
+<file path=ppt/slides/slide9.xml><?xml version="1.0" encoding="utf-8"?>
+<p:sld xmlns:a="http://schemas.openxmlformats.org/drawingml/2006/main" xmlns:r="http://schemas.openxmlformats.org/officeDocument/2006/relationships" xmlns:p="http://schemas.openxmlformats.org/presentationml/2006/main">
+  <p:cSld>
+    <p:spTree>
+      <p:nvGrpSpPr>
+        <p:cNvPr id="1" name=""/>
+        <p:cNvGrpSpPr/>
+        <p:nvPr/>
+      </p:nvGrpSpPr>
+      <p:grpSpPr>
+        <a:xfrm>
+          <a:off x="0" y="0"/>
+          <a:ext cx="0" cy="0"/>
+          <a:chOff x="0" y="0"/>
+          <a:chExt cx="0" cy="0"/>
+        </a:xfrm>
+      </p:grpSpPr>
+      <p:sp>
+        <p:nvSpPr>
+          <p:cNvPr id="2" name="Title 1"/>
+          <p:cNvSpPr>
+            <a:spLocks noGrp="1"/>
+          </p:cNvSpPr>
+          <p:nvPr>
+            <p:ph type="title"/>
+          </p:nvPr>
+        </p:nvSpPr>
+        <p:spPr/>
+        <p:txBody>
+          <a:bodyPr/>
+          <a:lstStyle/>
+          <a:p>
+            <a:r>
+              <a:rPr lang="en-US" dirty="0"/>
+              <a:t>Question 123.16.1</a:t>
+            </a:r>
+          </a:p>
+        </p:txBody>
+      </p:sp>
+      <p:sp>
+        <p:nvSpPr>
+          <p:cNvPr id="3" name="Content Placeholder 2"/>
+          <p:cNvSpPr>
+            <a:spLocks noGrp="1"/>
+          </p:cNvSpPr>
+          <p:nvPr>
+            <p:ph idx="1"/>
+          </p:nvPr>
+        </p:nvSpPr>
+        <p:spPr/>
+        <p:txBody>
+          <a:bodyPr/>
+          <a:lstStyle/>
+          <a:p>
+            <a:pPr>
+              <a:buNone/>
+            </a:pPr>
+            <a:r>
+              <a:rPr lang="en-US" dirty="0"/>
+              <a:t>Does disorder always increase in thermodynamic processes?</a:t>
+            </a:r>
+          </a:p>
+          <a:p>
+            <a:pPr marL="514350" indent="-514350">
+              <a:buFont typeface="+mj-lt"/>
+              <a:buAutoNum type="alphaLcParenR"/>
+            </a:pPr>
+            <a:r>
+              <a:rPr lang="en-US" dirty="0"/>
+              <a:t>Yes</a:t>
+            </a:r>
+          </a:p>
+          <a:p>
+            <a:pPr marL="514350" indent="-514350">
+              <a:buFont typeface="+mj-lt"/>
+              <a:buAutoNum type="alphaLcParenR"/>
+            </a:pPr>
+            <a:r>
+              <a:rPr lang="en-US" dirty="0"/>
+              <a:t>No</a:t>
+            </a:r>
+          </a:p>
+          <a:p>
+            <a:pPr marL="514350" indent="-514350">
+              <a:buFont typeface="+mj-lt"/>
+              <a:buAutoNum type="alphaLcParenR"/>
+            </a:pPr>
+            <a:r>
+              <a:rPr lang="en-US" dirty="0"/>
+              <a:t>Maybe (be prepared to explain)</a:t>
+            </a:r>
+          </a:p>
+          <a:p>
+            <a:pPr marL="514350" indent="-514350">
+              <a:buFont typeface="+mj-lt"/>
+              <a:buAutoNum type="alphaLcParenR"/>
+            </a:pPr>
+            <a:endParaRPr lang="en-US" dirty="0"/>
+          </a:p>
+        </p:txBody>
+      </p:sp>
+      <p:sp>
+        <p:nvSpPr>
+          <p:cNvPr id="4" name="Slide Number Placeholder 3"/>
+          <p:cNvSpPr>
+            <a:spLocks noGrp="1"/>
+          </p:cNvSpPr>
+          <p:nvPr>
+            <p:ph type="sldNum" sz="quarter" idx="12"/>
+          </p:nvPr>
+        </p:nvSpPr>
+        <p:spPr/>
+        <p:txBody>
+          <a:bodyPr/>
+          <a:lstStyle/>
+          <a:p>
+            <a:pPr>
+              <a:defRPr/>
+            </a:pPr>
+            <a:fld id="{4E87D1FB-7ED3-4D53-B026-4508F19EE3B8}" type="slidenum">
+              <a:rPr lang="en-US" smtClean="0"/>
+              <a:pPr>
+                <a:defRPr/>
+              </a:pPr>
+              <a:t>9</a:t>
+            </a:fld>
+            <a:endParaRPr lang="en-US"/>
+          </a:p>
+        </p:txBody>
+      </p:sp>
+    </p:spTree>
+    <p:extLst>
+      <p:ext uri="{BB962C8B-B14F-4D97-AF65-F5344CB8AC3E}">
+        <p14:creationId xmlns:p14="http://schemas.microsoft.com/office/powerpoint/2010/main" val="2413419914"/>
+      </p:ext>
+    </p:extLst>
   </p:cSld>
   <p:clrMapOvr>
     <a:masterClrMapping/>

</xml_diff>